<commit_message>
Co-op timelines with neighbours; Open in RCN Timeline; deck
- Co-op pages: each timeline shows the co-op's own history, then the
  history lane of each co-op it is tied to (same neighbours as graph
  and map): 19 of 22 pages; WECU, REI, Darigold keep a sentence.
- rcntimeline: 'Open in RCN Timeline' opens the item in the full tool
  (#tl= in a window named rcntimeline; localhost:8765 locally, the
  site's /assets/rcn-timeline/ elsewhere, or the item's tool field).
  Save-back not built.
- rcn-timeline.html: loads a new #tl= on hashchange (a second Open
  reused the tab but kept the first timeline), as one undo step; an
  earlier label stops at the next label in its row, not only the next
  bar. 22 solver tests pass.
- Deck (19 slides): map-with-ties and timeline slide replaces the
  native-map slide; new slides for timelines on the pages and for
  Open in RCN Timeline; limits and closing updated.

Co-Authored-By: Claude Opus 5.5 <noreply@anthropic.com>
</commit_message>
<xml_diff>
--- a/docs/whatcom-coops-four-lenses.pptx
+++ b/docs/whatcom-coops-four-lenses.pptx
@@ -22,6 +22,8 @@
     <p:sldId id="270" r:id="rId21"/>
     <p:sldId id="271" r:id="rId22"/>
     <p:sldId id="272" r:id="rId23"/>
+    <p:sldId id="273" r:id="rId24"/>
+    <p:sldId id="274" r:id="rId25"/>
   </p:sldIdLst>
   <p:sldSz cx="12188952" cy="6858000" type="screen4x3"/>
   <p:notesSz cx="6858000" cy="9144000"/>
@@ -5108,7 +5110,7 @@
                 </a:solidFill>
                 <a:latin typeface="Calibri"/>
               </a:rPr>
-              <a:t>FEDWIKI — MAP AND FRAME PLUGINS</a:t>
+              <a:t>FEDWIKI — RCN MAP AND RCN TIMELINE PLUGINS</a:t>
             </a:r>
           </a:p>
         </p:txBody>
@@ -5147,7 +5149,7 @@
                 </a:solidFill>
                 <a:latin typeface="Calibri"/>
               </a:rPr>
-              <a:t>Its map and its own website, inside the page</a:t>
+              <a:t>Its map, with the ties, and its history, with its neighbours</a:t>
             </a:r>
           </a:p>
         </p:txBody>
@@ -5161,7 +5163,7 @@
         <p:spPr>
           <a:xfrm>
             <a:off x="521207" y="1453896"/>
-            <a:ext cx="2743403" cy="4672583"/>
+            <a:ext cx="2675030" cy="4672583"/>
           </a:xfrm>
           <a:prstGeom prst="rect">
             <a:avLst/>
@@ -5198,7 +5200,7 @@
       </p:sp>
       <p:pic>
         <p:nvPicPr>
-          <p:cNvPr id="6" name="Picture 5" descr="11-wiki-map-site.jpg"/>
+          <p:cNvPr id="6" name="Picture 5" descr="13-wiki-map-timeline.jpg"/>
           <p:cNvPicPr>
             <a:picLocks noChangeAspect="1"/>
           </p:cNvPicPr>
@@ -5213,7 +5215,7 @@
         <p:spPr>
           <a:xfrm>
             <a:off x="548640" y="1481328"/>
-            <a:ext cx="2688539" cy="4617720"/>
+            <a:ext cx="2620166" cy="4617720"/>
           </a:xfrm>
           <a:prstGeom prst="rect">
             <a:avLst/>
@@ -5296,7 +5298,7 @@
                 </a:solidFill>
                 <a:latin typeface="Calibri"/>
               </a:rPr>
-              <a:t>—  A Map item — FedWiki’s own map plugin — shows this co-op and the co-ops it is tied to. Each point is a wiki link to that co-op’s page.</a:t>
+              <a:t>—  An RCN Map item draws this co-op and the co-ops it is tied to, with the ties in their colours and line styles. Click a point and its page opens beside this one.</a:t>
             </a:r>
           </a:p>
           <a:p>
@@ -5315,7 +5317,7 @@
                 </a:solidFill>
                 <a:latin typeface="Calibri"/>
               </a:rPr>
-              <a:t>—  The map is plain text, one line per point, so anyone can edit it in the page. It works on any wiki with nothing uploaded.</a:t>
+              <a:t>—  An RCN Timeline item draws the co-op’s own history first, then the history of each co-op it is tied to: the same neighbours as the graph and the map, now in time.</a:t>
             </a:r>
           </a:p>
           <a:p>
@@ -5334,7 +5336,7 @@
                 </a:solidFill>
                 <a:latin typeface="Calibri"/>
               </a:rPr>
-              <a:t>—  It draws points, not ties; the graph just above carries the ties. The table’s Map button draws them on a map.</a:t>
+              <a:t>—  Hover a bar for its dates, how uncertain they are, who says so and how sure. Click it and that co-op’s page opens.</a:t>
             </a:r>
           </a:p>
           <a:p>
@@ -5353,7 +5355,7 @@
                 </a:solidFill>
                 <a:latin typeface="Calibri"/>
               </a:rPr>
-              <a:t>—  A Frame item — used only for this — shows the co-op’s own website, live, under the map.</a:t>
+              <a:t>—  “Open in RCN Timeline ↗” opens the full tool with this timeline in it.</a:t>
             </a:r>
           </a:p>
           <a:p>
@@ -5372,7 +5374,7 @@
                 </a:solidFill>
                 <a:latin typeface="Calibri"/>
               </a:rPr>
-              <a:t>—  11 of the 22 sites show inside the page. The other 11 refuse to be framed, put up a bot check, are down, or have no site; those pages link out and say why.</a:t>
+              <a:t>—  A Frame item, used only for this, shows the co-op’s own website below: 11 of the 22 sites allow it; the rest link out and say why.</a:t>
             </a:r>
           </a:p>
         </p:txBody>
@@ -5411,7 +5413,7 @@
                 </a:solidFill>
                 <a:latin typeface="Calibri"/>
               </a:rPr>
-              <a:t>Screenshot · Community Food Co-op, scrolled to its map and website</a:t>
+              <a:t>Screenshot · North Cascades Meat Producers Cooperative, scrolled to its map and timeline</a:t>
             </a:r>
           </a:p>
         </p:txBody>
@@ -5598,7 +5600,7 @@
                 </a:solidFill>
                 <a:latin typeface="Calibri"/>
               </a:rPr>
-              <a:t>FEDWIKI — TABLE PLUGIN</a:t>
+              <a:t>FEDWIKI — RCN TIMELINE PLUGIN</a:t>
             </a:r>
           </a:p>
         </p:txBody>
@@ -5637,7 +5639,7 @@
                 </a:solidFill>
                 <a:latin typeface="Calibri"/>
               </a:rPr>
-              <a:t>The FedWiki table plugin: all 22 co-ops on the index page</a:t>
+              <a:t>A timeline on 19 co-op pages, and the whole history on the index</a:t>
             </a:r>
           </a:p>
         </p:txBody>
@@ -5651,7 +5653,7 @@
         <p:spPr>
           <a:xfrm>
             <a:off x="521207" y="1453896"/>
-            <a:ext cx="3255264" cy="2138845"/>
+            <a:ext cx="3086100" cy="2935224"/>
           </a:xfrm>
           <a:prstGeom prst="rect">
             <a:avLst/>
@@ -5688,7 +5690,7 @@
       </p:sp>
       <p:pic>
         <p:nvPicPr>
-          <p:cNvPr id="6" name="Picture 5" descr="12-wiki-table-item.jpg"/>
+          <p:cNvPr id="6" name="Picture 5" descr="14-wiki-timeline-coop.jpg"/>
           <p:cNvPicPr>
             <a:picLocks noChangeAspect="1"/>
           </p:cNvPicPr>
@@ -5703,7 +5705,7 @@
         <p:spPr>
           <a:xfrm>
             <a:off x="548640" y="1481328"/>
-            <a:ext cx="3200400" cy="2083981"/>
+            <a:ext cx="3031236" cy="2880360"/>
           </a:xfrm>
           <a:prstGeom prst="rect">
             <a:avLst/>
@@ -5718,8 +5720,8 @@
         </p:nvSpPr>
         <p:spPr>
           <a:xfrm>
-            <a:off x="548640" y="3638461"/>
-            <a:ext cx="3840480" cy="274320"/>
+            <a:off x="548640" y="4434840"/>
+            <a:ext cx="5120640" cy="274320"/>
           </a:xfrm>
           <a:prstGeom prst="rect">
             <a:avLst/>
@@ -5744,7 +5746,7 @@
                 </a:solidFill>
                 <a:latin typeface="Calibri"/>
               </a:rPr>
-              <a:t>The rcntable item on the index page</a:t>
+              <a:t>Community Food Co-op: its own history, then the five co-ops it is tied to</a:t>
             </a:r>
           </a:p>
         </p:txBody>
@@ -5757,8 +5759,8 @@
         </p:nvSpPr>
         <p:spPr>
           <a:xfrm>
-            <a:off x="548640" y="3976789"/>
-            <a:ext cx="3931920" cy="2651760"/>
+            <a:off x="548640" y="4773168"/>
+            <a:ext cx="5852160" cy="1828800"/>
           </a:xfrm>
           <a:prstGeom prst="rect">
             <a:avLst/>
@@ -5786,7 +5788,7 @@
                 </a:solidFill>
                 <a:latin typeface="Calibri"/>
               </a:rPr>
-              <a:t>—  The item names the records: database whatcomcoops, kind Coop.</a:t>
+              <a:t>—  Each interval names the co-op it belongs to, so a page draws the co-op’s own bars and its neighbours’ without a second list to keep in step.</a:t>
             </a:r>
           </a:p>
           <a:p>
@@ -5805,7 +5807,7 @@
                 </a:solidFill>
                 <a:latin typeface="Calibri"/>
               </a:rPr>
-              <a:t>—  Open Table ↗ opens the RCN Table beside the wiki — the same table as slide 9.</a:t>
+              <a:t>—  Grey bars are what a co-op was before: A-1 Builders before A1DesignBuild, the Co-op Education Project before Cascade Cooperatives.</a:t>
             </a:r>
           </a:p>
           <a:p>
@@ -5824,26 +5826,7 @@
                 </a:solidFill>
                 <a:latin typeface="Calibri"/>
               </a:rPr>
-              <a:t>—  At home it reads Neo4j live through substrate/api.py. On a hosted wiki it reads the exported folder in the site’s own assets, so each site is its own database.</a:t>
-            </a:r>
-          </a:p>
-          <a:p>
-            <a:pPr>
-              <a:lnSpc>
-                <a:spcPct val="110000"/>
-              </a:lnSpc>
-              <a:spcAft>
-                <a:spcPts val="300"/>
-              </a:spcAft>
-            </a:pPr>
-            <a:r>
-              <a:rPr sz="1200">
-                <a:solidFill>
-                  <a:srgbClr val="475569"/>
-                </a:solidFill>
-                <a:latin typeface="Calibri"/>
-              </a:rPr>
-              <a:t>—  Every name in the table opens that co-op’s page in the lineup.</a:t>
+              <a:t>—  Only WECU, REI and Darigold have a single bar and no ties; their pages point to the whole timeline instead.</a:t>
             </a:r>
           </a:p>
         </p:txBody>
@@ -5856,8 +5839,8 @@
         </p:nvSpPr>
         <p:spPr>
           <a:xfrm>
-            <a:off x="4727448" y="1453896"/>
-            <a:ext cx="6912864" cy="4068451"/>
+            <a:off x="6922007" y="1453896"/>
+            <a:ext cx="2902077" cy="4901183"/>
           </a:xfrm>
           <a:prstGeom prst="rect">
             <a:avLst/>
@@ -5894,7 +5877,7 @@
       </p:sp>
       <p:pic>
         <p:nvPicPr>
-          <p:cNvPr id="10" name="Picture 9" descr="07-table.jpg"/>
+          <p:cNvPr id="10" name="Picture 9" descr="16-wiki-timeline-index.jpg"/>
           <p:cNvPicPr>
             <a:picLocks noChangeAspect="1"/>
           </p:cNvPicPr>
@@ -5908,8 +5891,8 @@
         </p:blipFill>
         <p:spPr>
           <a:xfrm>
-            <a:off x="4754880" y="1481328"/>
-            <a:ext cx="6858000" cy="4013587"/>
+            <a:off x="6949440" y="1481328"/>
+            <a:ext cx="2847213" cy="4846320"/>
           </a:xfrm>
           <a:prstGeom prst="rect">
             <a:avLst/>
@@ -5924,8 +5907,8 @@
         </p:nvSpPr>
         <p:spPr>
           <a:xfrm>
-            <a:off x="4754880" y="5568067"/>
-            <a:ext cx="6858000" cy="274320"/>
+            <a:off x="6949440" y="6400800"/>
+            <a:ext cx="4663440" cy="274320"/>
           </a:xfrm>
           <a:prstGeom prst="rect">
             <a:avLst/>
@@ -5950,7 +5933,7 @@
                 </a:solidFill>
                 <a:latin typeface="Calibri"/>
               </a:rPr>
-              <a:t>What Open Table shows</a:t>
+              <a:t>The index page: 35 bars, 1918 to today</a:t>
             </a:r>
           </a:p>
         </p:txBody>
@@ -6137,7 +6120,7 @@
                 </a:solidFill>
                 <a:latin typeface="Calibri"/>
               </a:rPr>
-              <a:t>FEDWIKI — HOW IT WENT</a:t>
+              <a:t>FEDWIKI — OPEN IN RCN TIMELINE</a:t>
             </a:r>
           </a:p>
         </p:txBody>
@@ -6176,7 +6159,7 @@
                 </a:solidFill>
                 <a:latin typeface="Calibri"/>
               </a:rPr>
-              <a:t>Making it work: what broke, and what it cannot do</a:t>
+              <a:t>One click from the page to the full Timeline tool</a:t>
             </a:r>
           </a:p>
         </p:txBody>
@@ -6189,19 +6172,17 @@
         </p:nvSpPr>
         <p:spPr>
           <a:xfrm>
-            <a:off x="548640" y="1554480"/>
-            <a:ext cx="5486400" cy="3017520"/>
+            <a:off x="521207" y="1453896"/>
+            <a:ext cx="6380338" cy="4672583"/>
           </a:xfrm>
           <a:prstGeom prst="rect">
             <a:avLst/>
           </a:prstGeom>
           <a:solidFill>
-            <a:srgbClr val="FFFFFF"/>
+            <a:srgbClr val="E2E8F0"/>
           </a:solidFill>
-          <a:ln w="12700">
-            <a:solidFill>
-              <a:srgbClr val="E2E8F0"/>
-            </a:solidFill>
+          <a:ln>
+            <a:noFill/>
           </a:ln>
           <a:effectLst/>
         </p:spPr>
@@ -6227,16 +6208,40 @@
           </a:p>
         </p:txBody>
       </p:sp>
-      <p:sp>
-        <p:nvSpPr>
-          <p:cNvPr id="6" name="TextBox 5"/>
-          <p:cNvSpPr txBox="1"/>
-          <p:nvPr/>
-        </p:nvSpPr>
-        <p:spPr>
-          <a:xfrm>
-            <a:off x="777240" y="1691640"/>
-            <a:ext cx="5029200" cy="274320"/>
+      <p:pic>
+        <p:nvPicPr>
+          <p:cNvPr id="6" name="Picture 5" descr="15-timeline-tool-opened.jpg"/>
+          <p:cNvPicPr>
+            <a:picLocks noChangeAspect="1"/>
+          </p:cNvPicPr>
+          <p:nvPr/>
+        </p:nvPicPr>
+        <p:blipFill>
+          <a:blip r:embed="rId2"/>
+          <a:stretch>
+            <a:fillRect/>
+          </a:stretch>
+        </p:blipFill>
+        <p:spPr>
+          <a:xfrm>
+            <a:off x="548640" y="1481328"/>
+            <a:ext cx="6325474" cy="4617720"/>
+          </a:xfrm>
+          <a:prstGeom prst="rect">
+            <a:avLst/>
+          </a:prstGeom>
+        </p:spPr>
+      </p:pic>
+      <p:sp>
+        <p:nvSpPr>
+          <p:cNvPr id="7" name="TextBox 6"/>
+          <p:cNvSpPr txBox="1"/>
+          <p:nvPr/>
+        </p:nvSpPr>
+        <p:spPr>
+          <a:xfrm>
+            <a:off x="8869680" y="1481328"/>
+            <a:ext cx="2926080" cy="274320"/>
           </a:xfrm>
           <a:prstGeom prst="rect">
             <a:avLst/>
@@ -6257,25 +6262,25 @@
             <a:r>
               <a:rPr sz="1100" b="1" i="0">
                 <a:solidFill>
-                  <a:srgbClr val="1A7A4A"/>
-                </a:solidFill>
-                <a:latin typeface="Calibri"/>
-              </a:rPr>
-              <a:t>FIXED</a:t>
-            </a:r>
-          </a:p>
-        </p:txBody>
-      </p:sp>
-      <p:sp>
-        <p:nvSpPr>
-          <p:cNvPr id="7" name="TextBox 6"/>
-          <p:cNvSpPr txBox="1"/>
-          <p:nvPr/>
-        </p:nvSpPr>
-        <p:spPr>
-          <a:xfrm>
-            <a:off x="777240" y="2011680"/>
-            <a:ext cx="5029200" cy="2468880"/>
+                  <a:srgbClr val="B45309"/>
+                </a:solidFill>
+                <a:latin typeface="Calibri"/>
+              </a:rPr>
+              <a:t>WHAT YOU ARE SEEING</a:t>
+            </a:r>
+          </a:p>
+        </p:txBody>
+      </p:sp>
+      <p:sp>
+        <p:nvSpPr>
+          <p:cNvPr id="8" name="TextBox 7"/>
+          <p:cNvSpPr txBox="1"/>
+          <p:nvPr/>
+        </p:nvSpPr>
+        <p:spPr>
+          <a:xfrm>
+            <a:off x="8869680" y="1810512"/>
+            <a:ext cx="2834640" cy="4206240"/>
           </a:xfrm>
           <a:prstGeom prst="rect">
             <a:avLst/>
@@ -6293,17 +6298,17 @@
                 <a:spcPct val="110000"/>
               </a:lnSpc>
               <a:spcAft>
-                <a:spcPts val="600"/>
+                <a:spcPts val="800"/>
               </a:spcAft>
             </a:pPr>
             <a:r>
-              <a:rPr sz="1300">
+              <a:rPr sz="1400">
                 <a:solidFill>
                   <a:srgbClr val="475569"/>
                 </a:solidFill>
                 <a:latin typeface="Calibri"/>
               </a:rPr>
-              <a:t>—  Clicking a two-line name in a graph did nothing, or reloaded the wiki. Each co-op box is now one link. The real fix belongs in the Graph Tool, for every diagram.</a:t>
+              <a:t>—  “Open in RCN Timeline ↗” under any timeline opens the full tool in its own tab, with that timeline loaded: the North Cascades Meat co-op’s 8 intervals here.</a:t>
             </a:r>
           </a:p>
           <a:p>
@@ -6312,17 +6317,17 @@
                 <a:spcPct val="110000"/>
               </a:lnSpc>
               <a:spcAft>
-                <a:spcPts val="600"/>
+                <a:spcPts val="800"/>
               </a:spcAft>
             </a:pPr>
             <a:r>
-              <a:rPr sz="1300">
+              <a:rPr sz="1400">
                 <a:solidFill>
                   <a:srgbClr val="475569"/>
                 </a:solidFill>
                 <a:latin typeface="Calibri"/>
               </a:rPr>
-              <a:t>—  The maps first ran the RCN Map inside Frame items. That tied the pages to one wiki and needed files uploaded, so they now use FedWiki’s own Map plugin; Frame is kept for the websites only.</a:t>
+              <a:t>—  Nothing is lost on the way: the bar’s page and co-op links ride along, so the tool can hand them back.</a:t>
             </a:r>
           </a:p>
           <a:p>
@@ -6331,64 +6336,37 @@
                 <a:spcPct val="110000"/>
               </a:lnSpc>
               <a:spcAft>
-                <a:spcPts val="600"/>
+                <a:spcPts val="800"/>
               </a:spcAft>
             </a:pPr>
             <a:r>
-              <a:rPr sz="1300">
+              <a:rPr sz="1400">
                 <a:solidFill>
                   <a:srgbClr val="475569"/>
                 </a:solidFill>
                 <a:latin typeface="Calibri"/>
               </a:rPr>
-              <a:t>—  Along the way the table’s map learned to load on its own and to use the Esri basemap, so it also works when framed.</a:t>
-            </a:r>
-          </a:p>
-        </p:txBody>
-      </p:sp>
-      <p:sp>
-        <p:nvSpPr>
-          <p:cNvPr id="8" name="Rectangle 7"/>
-          <p:cNvSpPr/>
-          <p:nvPr/>
-        </p:nvSpPr>
-        <p:spPr>
-          <a:xfrm>
-            <a:off x="6263640" y="1554480"/>
-            <a:ext cx="5394960" cy="3017520"/>
-          </a:xfrm>
-          <a:prstGeom prst="rect">
-            <a:avLst/>
-          </a:prstGeom>
-          <a:solidFill>
-            <a:srgbClr val="FEF3C7"/>
-          </a:solidFill>
-          <a:ln w="12700">
-            <a:solidFill>
-              <a:srgbClr val="FDE047"/>
-            </a:solidFill>
-          </a:ln>
-          <a:effectLst/>
-        </p:spPr>
-        <p:style>
-          <a:lnRef idx="1">
-            <a:schemeClr val="accent1"/>
-          </a:lnRef>
-          <a:fillRef idx="3">
-            <a:schemeClr val="accent1"/>
-          </a:fillRef>
-          <a:effectRef idx="2">
-            <a:schemeClr val="accent1"/>
-          </a:effectRef>
-          <a:fontRef idx="minor">
-            <a:schemeClr val="lt1"/>
-          </a:fontRef>
-        </p:style>
-        <p:txBody>
-          <a:bodyPr rtlCol="0" anchor="ctr"/>
-          <a:lstStyle/>
-          <a:p>
-            <a:pPr algn="ctr"/>
+              <a:t>—  Open a second timeline from another page and the same tab switches to it, as one undo step.</a:t>
+            </a:r>
+          </a:p>
+          <a:p>
+            <a:pPr>
+              <a:lnSpc>
+                <a:spcPct val="110000"/>
+              </a:lnSpc>
+              <a:spcAft>
+                <a:spcPts val="800"/>
+              </a:spcAft>
+            </a:pPr>
+            <a:r>
+              <a:rPr sz="1400">
+                <a:solidFill>
+                  <a:srgbClr val="475569"/>
+                </a:solidFill>
+                <a:latin typeface="Calibri"/>
+              </a:rPr>
+              <a:t>—  Edits made in the tool do not come back to the page yet — saving back is the next step.</a:t>
+            </a:r>
           </a:p>
         </p:txBody>
       </p:sp>
@@ -6400,8 +6378,8 @@
         </p:nvSpPr>
         <p:spPr>
           <a:xfrm>
-            <a:off x="6492240" y="1691640"/>
-            <a:ext cx="4937760" cy="274320"/>
+            <a:off x="548640" y="6190488"/>
+            <a:ext cx="8001000" cy="274320"/>
           </a:xfrm>
           <a:prstGeom prst="rect">
             <a:avLst/>
@@ -6420,13 +6398,13 @@
               </a:lnSpc>
             </a:pPr>
             <a:r>
-              <a:rPr sz="1100" b="1" i="0">
-                <a:solidFill>
-                  <a:srgbClr val="854D0E"/>
-                </a:solidFill>
-                <a:latin typeface="Calibri"/>
-              </a:rPr>
-              <a:t>LIMITS</a:t>
+              <a:rPr sz="1000" b="0" i="1">
+                <a:solidFill>
+                  <a:srgbClr val="94A3B8"/>
+                </a:solidFill>
+                <a:latin typeface="Calibri"/>
+              </a:rPr>
+              <a:t>Screenshot · RCN Timeline, opened from the North Cascades Meat Producers Cooperative page</a:t>
             </a:r>
           </a:p>
         </p:txBody>
@@ -6434,106 +6412,6 @@
       <p:sp>
         <p:nvSpPr>
           <p:cNvPr id="10" name="TextBox 9"/>
-          <p:cNvSpPr txBox="1"/>
-          <p:nvPr/>
-        </p:nvSpPr>
-        <p:spPr>
-          <a:xfrm>
-            <a:off x="6492240" y="2011680"/>
-            <a:ext cx="4937760" cy="2468880"/>
-          </a:xfrm>
-          <a:prstGeom prst="rect">
-            <a:avLst/>
-          </a:prstGeom>
-          <a:noFill/>
-        </p:spPr>
-        <p:txBody>
-          <a:bodyPr wrap="square">
-            <a:spAutoFit/>
-          </a:bodyPr>
-          <a:lstStyle/>
-          <a:p>
-            <a:pPr>
-              <a:lnSpc>
-                <a:spcPct val="110000"/>
-              </a:lnSpc>
-              <a:spcAft>
-                <a:spcPts val="600"/>
-              </a:spcAft>
-            </a:pPr>
-            <a:r>
-              <a:rPr sz="1300">
-                <a:solidFill>
-                  <a:srgbClr val="854D0E"/>
-                </a:solidFill>
-                <a:latin typeface="Calibri"/>
-              </a:rPr>
-              <a:t>—  The per-page map shows points, not ties: we found no way in its text format to draw a line between two points. An RCN map plugin would.</a:t>
-            </a:r>
-          </a:p>
-          <a:p>
-            <a:pPr>
-              <a:lnSpc>
-                <a:spcPct val="110000"/>
-              </a:lnSpc>
-              <a:spcAft>
-                <a:spcPts val="600"/>
-              </a:spcAft>
-            </a:pPr>
-            <a:r>
-              <a:rPr sz="1300">
-                <a:solidFill>
-                  <a:srgbClr val="854D0E"/>
-                </a:solidFill>
-                <a:latin typeface="Calibri"/>
-              </a:rPr>
-              <a:t>—  Half the co-op websites cannot be shown in a page — ICU, REI, North Coast CU, A1DesignBuild and the Food Hub refuse; Bellingham Bay Builders’ bot check never finishes. Those pages link out.</a:t>
-            </a:r>
-          </a:p>
-        </p:txBody>
-      </p:sp>
-      <p:sp>
-        <p:nvSpPr>
-          <p:cNvPr id="11" name="TextBox 10"/>
-          <p:cNvSpPr txBox="1"/>
-          <p:nvPr/>
-        </p:nvSpPr>
-        <p:spPr>
-          <a:xfrm>
-            <a:off x="548640" y="4846320"/>
-            <a:ext cx="11064240" cy="731520"/>
-          </a:xfrm>
-          <a:prstGeom prst="rect">
-            <a:avLst/>
-          </a:prstGeom>
-          <a:noFill/>
-        </p:spPr>
-        <p:txBody>
-          <a:bodyPr wrap="square" anchor="t">
-            <a:spAutoFit/>
-          </a:bodyPr>
-          <a:lstStyle/>
-          <a:p>
-            <a:pPr algn="l">
-              <a:lnSpc>
-                <a:spcPct val="105000"/>
-              </a:lnSpc>
-            </a:pPr>
-            <a:r>
-              <a:rPr sz="1500" b="0" i="1">
-                <a:solidFill>
-                  <a:srgbClr val="475569"/>
-                </a:solidFill>
-                <a:latin typeface="Calibri"/>
-              </a:rPr>
-              <a:t>Checked in a real FedWiki (coops.localhost): a graph click opens the page beside, the Food Co-op’s map shows its 6 co-ops, and the websites were tested in the frame plugin’s own sandbox or by their headers — 11 show.</a:t>
-            </a:r>
-          </a:p>
-        </p:txBody>
-      </p:sp>
-      <p:sp>
-        <p:nvSpPr>
-          <p:cNvPr id="12" name="TextBox 11"/>
           <p:cNvSpPr txBox="1"/>
           <p:nvPr/>
         </p:nvSpPr>
@@ -6572,7 +6450,7 @@
       </p:sp>
       <p:sp>
         <p:nvSpPr>
-          <p:cNvPr id="13" name="TextBox 12"/>
+          <p:cNvPr id="11" name="TextBox 10"/>
           <p:cNvSpPr txBox="1"/>
           <p:nvPr/>
         </p:nvSpPr>
@@ -6650,7 +6528,7 @@
             <a:avLst/>
           </a:prstGeom>
           <a:solidFill>
-            <a:srgbClr val="D4A017"/>
+            <a:srgbClr val="B45309"/>
           </a:solidFill>
           <a:ln>
             <a:noFill/>
@@ -6709,11 +6587,11 @@
             <a:r>
               <a:rPr sz="1200" b="1" i="0">
                 <a:solidFill>
-                  <a:srgbClr val="D4A017"/>
-                </a:solidFill>
-                <a:latin typeface="Calibri"/>
-              </a:rPr>
-              <a:t>CONTACTS</a:t>
+                  <a:srgbClr val="B45309"/>
+                </a:solidFill>
+                <a:latin typeface="Calibri"/>
+              </a:rPr>
+              <a:t>FEDWIKI — TABLE PLUGIN</a:t>
             </a:r>
           </a:p>
         </p:txBody>
@@ -6752,7 +6630,7 @@
                 </a:solidFill>
                 <a:latin typeface="Calibri"/>
               </a:rPr>
-              <a:t>What the contact check found — and what to verify before calling</a:t>
+              <a:t>The FedWiki table plugin: all 22 co-ops on the index page</a:t>
             </a:r>
           </a:p>
         </p:txBody>
@@ -6765,8 +6643,547 @@
         </p:nvSpPr>
         <p:spPr>
           <a:xfrm>
+            <a:off x="521207" y="1453896"/>
+            <a:ext cx="3255264" cy="2138845"/>
+          </a:xfrm>
+          <a:prstGeom prst="rect">
+            <a:avLst/>
+          </a:prstGeom>
+          <a:solidFill>
+            <a:srgbClr val="E2E8F0"/>
+          </a:solidFill>
+          <a:ln>
+            <a:noFill/>
+          </a:ln>
+          <a:effectLst/>
+        </p:spPr>
+        <p:style>
+          <a:lnRef idx="1">
+            <a:schemeClr val="accent1"/>
+          </a:lnRef>
+          <a:fillRef idx="3">
+            <a:schemeClr val="accent1"/>
+          </a:fillRef>
+          <a:effectRef idx="2">
+            <a:schemeClr val="accent1"/>
+          </a:effectRef>
+          <a:fontRef idx="minor">
+            <a:schemeClr val="lt1"/>
+          </a:fontRef>
+        </p:style>
+        <p:txBody>
+          <a:bodyPr rtlCol="0" anchor="ctr"/>
+          <a:lstStyle/>
+          <a:p>
+            <a:pPr algn="ctr"/>
+          </a:p>
+        </p:txBody>
+      </p:sp>
+      <p:pic>
+        <p:nvPicPr>
+          <p:cNvPr id="6" name="Picture 5" descr="12-wiki-table-item.jpg"/>
+          <p:cNvPicPr>
+            <a:picLocks noChangeAspect="1"/>
+          </p:cNvPicPr>
+          <p:nvPr/>
+        </p:nvPicPr>
+        <p:blipFill>
+          <a:blip r:embed="rId2"/>
+          <a:stretch>
+            <a:fillRect/>
+          </a:stretch>
+        </p:blipFill>
+        <p:spPr>
+          <a:xfrm>
+            <a:off x="548640" y="1481328"/>
+            <a:ext cx="3200400" cy="2083981"/>
+          </a:xfrm>
+          <a:prstGeom prst="rect">
+            <a:avLst/>
+          </a:prstGeom>
+        </p:spPr>
+      </p:pic>
+      <p:sp>
+        <p:nvSpPr>
+          <p:cNvPr id="7" name="TextBox 6"/>
+          <p:cNvSpPr txBox="1"/>
+          <p:nvPr/>
+        </p:nvSpPr>
+        <p:spPr>
+          <a:xfrm>
+            <a:off x="548640" y="3638461"/>
+            <a:ext cx="3840480" cy="274320"/>
+          </a:xfrm>
+          <a:prstGeom prst="rect">
+            <a:avLst/>
+          </a:prstGeom>
+          <a:noFill/>
+        </p:spPr>
+        <p:txBody>
+          <a:bodyPr wrap="square" anchor="t">
+            <a:spAutoFit/>
+          </a:bodyPr>
+          <a:lstStyle/>
+          <a:p>
+            <a:pPr algn="l">
+              <a:lnSpc>
+                <a:spcPct val="105000"/>
+              </a:lnSpc>
+            </a:pPr>
+            <a:r>
+              <a:rPr sz="1000" b="0" i="1">
+                <a:solidFill>
+                  <a:srgbClr val="94A3B8"/>
+                </a:solidFill>
+                <a:latin typeface="Calibri"/>
+              </a:rPr>
+              <a:t>The rcntable item on the index page</a:t>
+            </a:r>
+          </a:p>
+        </p:txBody>
+      </p:sp>
+      <p:sp>
+        <p:nvSpPr>
+          <p:cNvPr id="8" name="TextBox 7"/>
+          <p:cNvSpPr txBox="1"/>
+          <p:nvPr/>
+        </p:nvSpPr>
+        <p:spPr>
+          <a:xfrm>
+            <a:off x="548640" y="3976789"/>
+            <a:ext cx="3931920" cy="2651760"/>
+          </a:xfrm>
+          <a:prstGeom prst="rect">
+            <a:avLst/>
+          </a:prstGeom>
+          <a:noFill/>
+        </p:spPr>
+        <p:txBody>
+          <a:bodyPr wrap="square">
+            <a:spAutoFit/>
+          </a:bodyPr>
+          <a:lstStyle/>
+          <a:p>
+            <a:pPr>
+              <a:lnSpc>
+                <a:spcPct val="110000"/>
+              </a:lnSpc>
+              <a:spcAft>
+                <a:spcPts val="300"/>
+              </a:spcAft>
+            </a:pPr>
+            <a:r>
+              <a:rPr sz="1200">
+                <a:solidFill>
+                  <a:srgbClr val="475569"/>
+                </a:solidFill>
+                <a:latin typeface="Calibri"/>
+              </a:rPr>
+              <a:t>—  The item names the records: database whatcomcoops, kind Coop.</a:t>
+            </a:r>
+          </a:p>
+          <a:p>
+            <a:pPr>
+              <a:lnSpc>
+                <a:spcPct val="110000"/>
+              </a:lnSpc>
+              <a:spcAft>
+                <a:spcPts val="300"/>
+              </a:spcAft>
+            </a:pPr>
+            <a:r>
+              <a:rPr sz="1200">
+                <a:solidFill>
+                  <a:srgbClr val="475569"/>
+                </a:solidFill>
+                <a:latin typeface="Calibri"/>
+              </a:rPr>
+              <a:t>—  Open Table ↗ opens the RCN Table beside the wiki — the same table as slide 9.</a:t>
+            </a:r>
+          </a:p>
+          <a:p>
+            <a:pPr>
+              <a:lnSpc>
+                <a:spcPct val="110000"/>
+              </a:lnSpc>
+              <a:spcAft>
+                <a:spcPts val="300"/>
+              </a:spcAft>
+            </a:pPr>
+            <a:r>
+              <a:rPr sz="1200">
+                <a:solidFill>
+                  <a:srgbClr val="475569"/>
+                </a:solidFill>
+                <a:latin typeface="Calibri"/>
+              </a:rPr>
+              <a:t>—  At home it reads Neo4j live through substrate/api.py. On a hosted wiki it reads the exported folder in the site’s own assets, so each site is its own database.</a:t>
+            </a:r>
+          </a:p>
+          <a:p>
+            <a:pPr>
+              <a:lnSpc>
+                <a:spcPct val="110000"/>
+              </a:lnSpc>
+              <a:spcAft>
+                <a:spcPts val="300"/>
+              </a:spcAft>
+            </a:pPr>
+            <a:r>
+              <a:rPr sz="1200">
+                <a:solidFill>
+                  <a:srgbClr val="475569"/>
+                </a:solidFill>
+                <a:latin typeface="Calibri"/>
+              </a:rPr>
+              <a:t>—  Every name in the table opens that co-op’s page in the lineup.</a:t>
+            </a:r>
+          </a:p>
+        </p:txBody>
+      </p:sp>
+      <p:sp>
+        <p:nvSpPr>
+          <p:cNvPr id="9" name="Rectangle 8"/>
+          <p:cNvSpPr/>
+          <p:nvPr/>
+        </p:nvSpPr>
+        <p:spPr>
+          <a:xfrm>
+            <a:off x="4727448" y="1453896"/>
+            <a:ext cx="6912864" cy="4068451"/>
+          </a:xfrm>
+          <a:prstGeom prst="rect">
+            <a:avLst/>
+          </a:prstGeom>
+          <a:solidFill>
+            <a:srgbClr val="E2E8F0"/>
+          </a:solidFill>
+          <a:ln>
+            <a:noFill/>
+          </a:ln>
+          <a:effectLst/>
+        </p:spPr>
+        <p:style>
+          <a:lnRef idx="1">
+            <a:schemeClr val="accent1"/>
+          </a:lnRef>
+          <a:fillRef idx="3">
+            <a:schemeClr val="accent1"/>
+          </a:fillRef>
+          <a:effectRef idx="2">
+            <a:schemeClr val="accent1"/>
+          </a:effectRef>
+          <a:fontRef idx="minor">
+            <a:schemeClr val="lt1"/>
+          </a:fontRef>
+        </p:style>
+        <p:txBody>
+          <a:bodyPr rtlCol="0" anchor="ctr"/>
+          <a:lstStyle/>
+          <a:p>
+            <a:pPr algn="ctr"/>
+          </a:p>
+        </p:txBody>
+      </p:sp>
+      <p:pic>
+        <p:nvPicPr>
+          <p:cNvPr id="10" name="Picture 9" descr="07-table.jpg"/>
+          <p:cNvPicPr>
+            <a:picLocks noChangeAspect="1"/>
+          </p:cNvPicPr>
+          <p:nvPr/>
+        </p:nvPicPr>
+        <p:blipFill>
+          <a:blip r:embed="rId3"/>
+          <a:stretch>
+            <a:fillRect/>
+          </a:stretch>
+        </p:blipFill>
+        <p:spPr>
+          <a:xfrm>
+            <a:off x="4754880" y="1481328"/>
+            <a:ext cx="6858000" cy="4013587"/>
+          </a:xfrm>
+          <a:prstGeom prst="rect">
+            <a:avLst/>
+          </a:prstGeom>
+        </p:spPr>
+      </p:pic>
+      <p:sp>
+        <p:nvSpPr>
+          <p:cNvPr id="11" name="TextBox 10"/>
+          <p:cNvSpPr txBox="1"/>
+          <p:nvPr/>
+        </p:nvSpPr>
+        <p:spPr>
+          <a:xfrm>
+            <a:off x="4754880" y="5568067"/>
+            <a:ext cx="6858000" cy="274320"/>
+          </a:xfrm>
+          <a:prstGeom prst="rect">
+            <a:avLst/>
+          </a:prstGeom>
+          <a:noFill/>
+        </p:spPr>
+        <p:txBody>
+          <a:bodyPr wrap="square" anchor="t">
+            <a:spAutoFit/>
+          </a:bodyPr>
+          <a:lstStyle/>
+          <a:p>
+            <a:pPr algn="l">
+              <a:lnSpc>
+                <a:spcPct val="105000"/>
+              </a:lnSpc>
+            </a:pPr>
+            <a:r>
+              <a:rPr sz="1000" b="0" i="1">
+                <a:solidFill>
+                  <a:srgbClr val="94A3B8"/>
+                </a:solidFill>
+                <a:latin typeface="Calibri"/>
+              </a:rPr>
+              <a:t>What Open Table shows</a:t>
+            </a:r>
+          </a:p>
+        </p:txBody>
+      </p:sp>
+      <p:sp>
+        <p:nvSpPr>
+          <p:cNvPr id="12" name="TextBox 11"/>
+          <p:cNvSpPr txBox="1"/>
+          <p:nvPr/>
+        </p:nvSpPr>
+        <p:spPr>
+          <a:xfrm>
+            <a:off x="548640" y="6446520"/>
+            <a:ext cx="5486400" cy="274320"/>
+          </a:xfrm>
+          <a:prstGeom prst="rect">
+            <a:avLst/>
+          </a:prstGeom>
+          <a:noFill/>
+        </p:spPr>
+        <p:txBody>
+          <a:bodyPr wrap="square" anchor="t">
+            <a:spAutoFit/>
+          </a:bodyPr>
+          <a:lstStyle/>
+          <a:p>
+            <a:pPr algn="l">
+              <a:lnSpc>
+                <a:spcPct val="105000"/>
+              </a:lnSpc>
+            </a:pPr>
+            <a:r>
+              <a:rPr sz="900" b="0" i="0">
+                <a:solidFill>
+                  <a:srgbClr val="94A3B8"/>
+                </a:solidFill>
+                <a:latin typeface="Calibri"/>
+              </a:rPr>
+              <a:t>Co-ops of Whatcom County · RCN</a:t>
+            </a:r>
+          </a:p>
+        </p:txBody>
+      </p:sp>
+      <p:sp>
+        <p:nvSpPr>
+          <p:cNvPr id="13" name="TextBox 12"/>
+          <p:cNvSpPr txBox="1"/>
+          <p:nvPr/>
+        </p:nvSpPr>
+        <p:spPr>
+          <a:xfrm>
+            <a:off x="11247120" y="6446520"/>
+            <a:ext cx="365760" cy="274320"/>
+          </a:xfrm>
+          <a:prstGeom prst="rect">
+            <a:avLst/>
+          </a:prstGeom>
+          <a:noFill/>
+        </p:spPr>
+        <p:txBody>
+          <a:bodyPr wrap="square" anchor="t">
+            <a:spAutoFit/>
+          </a:bodyPr>
+          <a:lstStyle/>
+          <a:p>
+            <a:pPr algn="r">
+              <a:lnSpc>
+                <a:spcPct val="105000"/>
+              </a:lnSpc>
+            </a:pPr>
+            <a:r>
+              <a:rPr sz="900" b="0" i="0">
+                <a:solidFill>
+                  <a:srgbClr val="94A3B8"/>
+                </a:solidFill>
+                <a:latin typeface="Calibri"/>
+              </a:rPr>
+              <a:t>16</a:t>
+            </a:r>
+          </a:p>
+        </p:txBody>
+      </p:sp>
+    </p:spTree>
+  </p:cSld>
+  <p:clrMapOvr>
+    <a:masterClrMapping/>
+  </p:clrMapOvr>
+</p:sld>
+</file>
+
+<file path=ppt/slides/slide17.xml><?xml version="1.0" encoding="utf-8"?>
+<p:sld xmlns:a="http://schemas.openxmlformats.org/drawingml/2006/main" xmlns:p="http://schemas.openxmlformats.org/presentationml/2006/main" xmlns:r="http://schemas.openxmlformats.org/officeDocument/2006/relationships">
+  <p:cSld>
+    <p:bg>
+      <p:bgPr>
+        <a:solidFill>
+          <a:srgbClr val="F8FAFC"/>
+        </a:solidFill>
+        <a:effectLst/>
+      </p:bgPr>
+    </p:bg>
+    <p:spTree>
+      <p:nvGrpSpPr>
+        <p:cNvPr id="1" name=""/>
+        <p:cNvGrpSpPr/>
+        <p:nvPr/>
+      </p:nvGrpSpPr>
+      <p:grpSpPr/>
+      <p:sp>
+        <p:nvSpPr>
+          <p:cNvPr id="2" name="Rectangle 1"/>
+          <p:cNvSpPr/>
+          <p:nvPr/>
+        </p:nvSpPr>
+        <p:spPr>
+          <a:xfrm>
+            <a:off x="548640" y="384048"/>
+            <a:ext cx="82296" cy="274320"/>
+          </a:xfrm>
+          <a:prstGeom prst="rect">
+            <a:avLst/>
+          </a:prstGeom>
+          <a:solidFill>
+            <a:srgbClr val="B45309"/>
+          </a:solidFill>
+          <a:ln>
+            <a:noFill/>
+          </a:ln>
+          <a:effectLst/>
+        </p:spPr>
+        <p:style>
+          <a:lnRef idx="1">
+            <a:schemeClr val="accent1"/>
+          </a:lnRef>
+          <a:fillRef idx="3">
+            <a:schemeClr val="accent1"/>
+          </a:fillRef>
+          <a:effectRef idx="2">
+            <a:schemeClr val="accent1"/>
+          </a:effectRef>
+          <a:fontRef idx="minor">
+            <a:schemeClr val="lt1"/>
+          </a:fontRef>
+        </p:style>
+        <p:txBody>
+          <a:bodyPr rtlCol="0" anchor="ctr"/>
+          <a:lstStyle/>
+          <a:p>
+            <a:pPr algn="ctr"/>
+          </a:p>
+        </p:txBody>
+      </p:sp>
+      <p:sp>
+        <p:nvSpPr>
+          <p:cNvPr id="3" name="TextBox 2"/>
+          <p:cNvSpPr txBox="1"/>
+          <p:nvPr/>
+        </p:nvSpPr>
+        <p:spPr>
+          <a:xfrm>
+            <a:off x="731520" y="365760"/>
+            <a:ext cx="7315200" cy="320040"/>
+          </a:xfrm>
+          <a:prstGeom prst="rect">
+            <a:avLst/>
+          </a:prstGeom>
+          <a:noFill/>
+        </p:spPr>
+        <p:txBody>
+          <a:bodyPr wrap="square" anchor="t">
+            <a:spAutoFit/>
+          </a:bodyPr>
+          <a:lstStyle/>
+          <a:p>
+            <a:pPr algn="l">
+              <a:lnSpc>
+                <a:spcPct val="105000"/>
+              </a:lnSpc>
+            </a:pPr>
+            <a:r>
+              <a:rPr sz="1200" b="1" i="0">
+                <a:solidFill>
+                  <a:srgbClr val="B45309"/>
+                </a:solidFill>
+                <a:latin typeface="Calibri"/>
+              </a:rPr>
+              <a:t>FEDWIKI — HOW IT WENT</a:t>
+            </a:r>
+          </a:p>
+        </p:txBody>
+      </p:sp>
+      <p:sp>
+        <p:nvSpPr>
+          <p:cNvPr id="4" name="TextBox 3"/>
+          <p:cNvSpPr txBox="1"/>
+          <p:nvPr/>
+        </p:nvSpPr>
+        <p:spPr>
+          <a:xfrm>
+            <a:off x="548640" y="713232"/>
+            <a:ext cx="11155680" cy="640080"/>
+          </a:xfrm>
+          <a:prstGeom prst="rect">
+            <a:avLst/>
+          </a:prstGeom>
+          <a:noFill/>
+        </p:spPr>
+        <p:txBody>
+          <a:bodyPr wrap="square" anchor="t">
+            <a:spAutoFit/>
+          </a:bodyPr>
+          <a:lstStyle/>
+          <a:p>
+            <a:pPr algn="l">
+              <a:lnSpc>
+                <a:spcPct val="105000"/>
+              </a:lnSpc>
+            </a:pPr>
+            <a:r>
+              <a:rPr sz="2800" b="1" i="0">
+                <a:solidFill>
+                  <a:srgbClr val="0F172A"/>
+                </a:solidFill>
+                <a:latin typeface="Calibri"/>
+              </a:rPr>
+              <a:t>Making it work: what broke, and what it cannot do</a:t>
+            </a:r>
+          </a:p>
+        </p:txBody>
+      </p:sp>
+      <p:sp>
+        <p:nvSpPr>
+          <p:cNvPr id="5" name="Rectangle 4"/>
+          <p:cNvSpPr/>
+          <p:nvPr/>
+        </p:nvSpPr>
+        <p:spPr>
+          <a:xfrm>
             <a:off x="548640" y="1554480"/>
-            <a:ext cx="5486400" cy="3108960"/>
+            <a:ext cx="5486400" cy="3429000"/>
           </a:xfrm>
           <a:prstGeom prst="rect">
             <a:avLst/>
@@ -6837,7 +7254,7 @@
                 </a:solidFill>
                 <a:latin typeface="Calibri"/>
               </a:rPr>
-              <a:t>CORRECTED IN THE DATA</a:t>
+              <a:t>FIXED</a:t>
             </a:r>
           </a:p>
         </p:txBody>
@@ -6851,7 +7268,7 @@
         <p:spPr>
           <a:xfrm>
             <a:off x="777240" y="2011680"/>
-            <a:ext cx="5029200" cy="2560320"/>
+            <a:ext cx="5029200" cy="2468880"/>
           </a:xfrm>
           <a:prstGeom prst="rect">
             <a:avLst/>
@@ -6879,7 +7296,7 @@
                 </a:solidFill>
                 <a:latin typeface="Calibri"/>
               </a:rPr>
-              <a:t>—  Community to Community has moved: 1319 Cornwall Ave, Suite 101 (the map pin is moved).</a:t>
+              <a:t>—  Clicking a two-line name in a graph did nothing, or reloaded the wiki. Each co-op box is now one link. The real fix belongs in the Graph Tool, for every diagram.</a:t>
             </a:r>
           </a:p>
           <a:p>
@@ -6898,7 +7315,7 @@
                 </a:solidFill>
                 <a:latin typeface="Calibri"/>
               </a:rPr>
-              <a:t>—  Cascade Cooperatives incorporated in January 2022, not 2019; it began in 2014 as the Co-op Education Project.</a:t>
+              <a:t>—  Maps first ran inside Frame items, which tied pages to one wiki. Two plugins of our own replaced them — RCN Map and RCN Timeline — and Frame is kept for websites only.</a:t>
             </a:r>
           </a:p>
           <a:p>
@@ -6917,7 +7334,7 @@
                 </a:solidFill>
                 <a:latin typeface="Calibri"/>
               </a:rPr>
-              <a:t>—  CHS Northwest in Lynden is at 402 Main St.</a:t>
+              <a:t>—  Timeline labels ran over each other in a narrow column. They now stop where the next begins, in the page and in the full tool.</a:t>
             </a:r>
           </a:p>
           <a:p>
@@ -6936,26 +7353,7 @@
                 </a:solidFill>
                 <a:latin typeface="Calibri"/>
               </a:rPr>
-              <a:t>—  Industrial Credit Union’s website is industrialcu.com.</a:t>
-            </a:r>
-          </a:p>
-          <a:p>
-            <a:pPr>
-              <a:lnSpc>
-                <a:spcPct val="110000"/>
-              </a:lnSpc>
-              <a:spcAft>
-                <a:spcPts val="600"/>
-              </a:spcAft>
-            </a:pPr>
-            <a:r>
-              <a:rPr sz="1300">
-                <a:solidFill>
-                  <a:srgbClr val="475569"/>
-                </a:solidFill>
-                <a:latin typeface="Calibri"/>
-              </a:rPr>
-              <a:t>—  Yellow Cab Co-op has its own site, yellowcabcoop.com.</a:t>
+              <a:t>—  The Timeline tool dropped fields it did not know, so a co-op link vanished on save; and a second “Open” left it on the first timeline. Both fixed.</a:t>
             </a:r>
           </a:p>
         </p:txBody>
@@ -6969,7 +7367,7 @@
         <p:spPr>
           <a:xfrm>
             <a:off x="6263640" y="1554480"/>
-            <a:ext cx="5394960" cy="3108960"/>
+            <a:ext cx="5394960" cy="3429000"/>
           </a:xfrm>
           <a:prstGeom prst="rect">
             <a:avLst/>
@@ -7040,7 +7438,7 @@
                 </a:solidFill>
                 <a:latin typeface="Calibri"/>
               </a:rPr>
-              <a:t>VERIFY BEFORE RELYING ON IT</a:t>
+              <a:t>LIMITS</a:t>
             </a:r>
           </a:p>
         </p:txBody>
@@ -7054,7 +7452,7 @@
         <p:spPr>
           <a:xfrm>
             <a:off x="6492240" y="2011680"/>
-            <a:ext cx="4937760" cy="2560320"/>
+            <a:ext cx="4937760" cy="2468880"/>
           </a:xfrm>
           <a:prstGeom prst="rect">
             <a:avLst/>
@@ -7082,7 +7480,7 @@
                 </a:solidFill>
                 <a:latin typeface="Calibri"/>
               </a:rPr>
-              <a:t>—  Community Media Cooperative — media-coop.com no longer resolves; it may have closed.</a:t>
+              <a:t>—  The RCN Map and RCN Timeline plugins run on the local wiki. On Wiki Café they need an npm publish and an image rebuild first; until then, build pages with --map native.</a:t>
             </a:r>
           </a:p>
           <a:p>
@@ -7101,7 +7499,7 @@
                 </a:solidFill>
                 <a:latin typeface="Calibri"/>
               </a:rPr>
-              <a:t>—  Cascadia Deaf Nation — website answers “Payment Required”; it may have lapsed.</a:t>
+              <a:t>—  Edits in the full Timeline tool do not save back to the page yet.</a:t>
             </a:r>
           </a:p>
           <a:p>
@@ -7120,45 +7518,7 @@
                 </a:solidFill>
                 <a:latin typeface="Calibri"/>
               </a:rPr>
-              <a:t>—  Bellingham Bay Builders — only the 2004 founders are published, not the current owner-members.</a:t>
-            </a:r>
-          </a:p>
-          <a:p>
-            <a:pPr>
-              <a:lnSpc>
-                <a:spcPct val="110000"/>
-              </a:lnSpc>
-              <a:spcAft>
-                <a:spcPts val="600"/>
-              </a:spcAft>
-            </a:pPr>
-            <a:r>
-              <a:rPr sz="1300">
-                <a:solidFill>
-                  <a:srgbClr val="854D0E"/>
-                </a:solidFill>
-                <a:latin typeface="Calibri"/>
-              </a:rPr>
-              <a:t>—  WestEdge CU, Yellow Cab Co-op, Circle of Life, CHS — no leader named on their own sites.</a:t>
-            </a:r>
-          </a:p>
-          <a:p>
-            <a:pPr>
-              <a:lnSpc>
-                <a:spcPct val="110000"/>
-              </a:lnSpc>
-              <a:spcAft>
-                <a:spcPts val="600"/>
-              </a:spcAft>
-            </a:pPr>
-            <a:r>
-              <a:rPr sz="1300">
-                <a:solidFill>
-                  <a:srgbClr val="854D0E"/>
-                </a:solidFill>
-                <a:latin typeface="Calibri"/>
-              </a:rPr>
-              <a:t>—  Tierra y Libertad — no website of its own; reach it through C2C.</a:t>
+              <a:t>—  Half the co-op websites cannot be shown in a page — ICU, REI, North Coast CU, A1DesignBuild and the Food Hub refuse; Bellingham Bay Builders’ bot check never finishes. Those pages link out.</a:t>
             </a:r>
           </a:p>
         </p:txBody>
@@ -7171,7 +7531,7 @@
         </p:nvSpPr>
         <p:spPr>
           <a:xfrm>
-            <a:off x="548640" y="4983480"/>
+            <a:off x="548640" y="5212080"/>
             <a:ext cx="11064240" cy="731520"/>
           </a:xfrm>
           <a:prstGeom prst="rect">
@@ -7197,7 +7557,7 @@
                 </a:solidFill>
                 <a:latin typeface="Calibri"/>
               </a:rPr>
-              <a:t>Every contact carries “Checked Sep 2026” and the page it was read from. Phones and names change; the date says how far to trust them.</a:t>
+              <a:t>Checked in a real FedWiki (coops.localhost) with real clicks: a graph box, a map point and a timeline bar each open their page beside; Open in RCN Timeline loads the page’s timeline; the websites were tested in the frame plugin’s own sandbox or by their headers — 11 show.</a:t>
             </a:r>
           </a:p>
         </p:txBody>
@@ -7275,7 +7635,7 @@
                 </a:solidFill>
                 <a:latin typeface="Calibri"/>
               </a:rPr>
-              <a:t>16</a:t>
+              <a:t>17</a:t>
             </a:r>
           </a:p>
         </p:txBody>
@@ -7288,7 +7648,678 @@
 </p:sld>
 </file>
 
-<file path=ppt/slides/slide17.xml><?xml version="1.0" encoding="utf-8"?>
+<file path=ppt/slides/slide18.xml><?xml version="1.0" encoding="utf-8"?>
+<p:sld xmlns:a="http://schemas.openxmlformats.org/drawingml/2006/main" xmlns:p="http://schemas.openxmlformats.org/presentationml/2006/main" xmlns:r="http://schemas.openxmlformats.org/officeDocument/2006/relationships">
+  <p:cSld>
+    <p:bg>
+      <p:bgPr>
+        <a:solidFill>
+          <a:srgbClr val="F8FAFC"/>
+        </a:solidFill>
+        <a:effectLst/>
+      </p:bgPr>
+    </p:bg>
+    <p:spTree>
+      <p:nvGrpSpPr>
+        <p:cNvPr id="1" name=""/>
+        <p:cNvGrpSpPr/>
+        <p:nvPr/>
+      </p:nvGrpSpPr>
+      <p:grpSpPr/>
+      <p:sp>
+        <p:nvSpPr>
+          <p:cNvPr id="2" name="Rectangle 1"/>
+          <p:cNvSpPr/>
+          <p:nvPr/>
+        </p:nvSpPr>
+        <p:spPr>
+          <a:xfrm>
+            <a:off x="548640" y="384048"/>
+            <a:ext cx="82296" cy="274320"/>
+          </a:xfrm>
+          <a:prstGeom prst="rect">
+            <a:avLst/>
+          </a:prstGeom>
+          <a:solidFill>
+            <a:srgbClr val="D4A017"/>
+          </a:solidFill>
+          <a:ln>
+            <a:noFill/>
+          </a:ln>
+          <a:effectLst/>
+        </p:spPr>
+        <p:style>
+          <a:lnRef idx="1">
+            <a:schemeClr val="accent1"/>
+          </a:lnRef>
+          <a:fillRef idx="3">
+            <a:schemeClr val="accent1"/>
+          </a:fillRef>
+          <a:effectRef idx="2">
+            <a:schemeClr val="accent1"/>
+          </a:effectRef>
+          <a:fontRef idx="minor">
+            <a:schemeClr val="lt1"/>
+          </a:fontRef>
+        </p:style>
+        <p:txBody>
+          <a:bodyPr rtlCol="0" anchor="ctr"/>
+          <a:lstStyle/>
+          <a:p>
+            <a:pPr algn="ctr"/>
+          </a:p>
+        </p:txBody>
+      </p:sp>
+      <p:sp>
+        <p:nvSpPr>
+          <p:cNvPr id="3" name="TextBox 2"/>
+          <p:cNvSpPr txBox="1"/>
+          <p:nvPr/>
+        </p:nvSpPr>
+        <p:spPr>
+          <a:xfrm>
+            <a:off x="731520" y="365760"/>
+            <a:ext cx="7315200" cy="320040"/>
+          </a:xfrm>
+          <a:prstGeom prst="rect">
+            <a:avLst/>
+          </a:prstGeom>
+          <a:noFill/>
+        </p:spPr>
+        <p:txBody>
+          <a:bodyPr wrap="square" anchor="t">
+            <a:spAutoFit/>
+          </a:bodyPr>
+          <a:lstStyle/>
+          <a:p>
+            <a:pPr algn="l">
+              <a:lnSpc>
+                <a:spcPct val="105000"/>
+              </a:lnSpc>
+            </a:pPr>
+            <a:r>
+              <a:rPr sz="1200" b="1" i="0">
+                <a:solidFill>
+                  <a:srgbClr val="D4A017"/>
+                </a:solidFill>
+                <a:latin typeface="Calibri"/>
+              </a:rPr>
+              <a:t>CONTACTS</a:t>
+            </a:r>
+          </a:p>
+        </p:txBody>
+      </p:sp>
+      <p:sp>
+        <p:nvSpPr>
+          <p:cNvPr id="4" name="TextBox 3"/>
+          <p:cNvSpPr txBox="1"/>
+          <p:nvPr/>
+        </p:nvSpPr>
+        <p:spPr>
+          <a:xfrm>
+            <a:off x="548640" y="713232"/>
+            <a:ext cx="11155680" cy="640080"/>
+          </a:xfrm>
+          <a:prstGeom prst="rect">
+            <a:avLst/>
+          </a:prstGeom>
+          <a:noFill/>
+        </p:spPr>
+        <p:txBody>
+          <a:bodyPr wrap="square" anchor="t">
+            <a:spAutoFit/>
+          </a:bodyPr>
+          <a:lstStyle/>
+          <a:p>
+            <a:pPr algn="l">
+              <a:lnSpc>
+                <a:spcPct val="105000"/>
+              </a:lnSpc>
+            </a:pPr>
+            <a:r>
+              <a:rPr sz="2800" b="1" i="0">
+                <a:solidFill>
+                  <a:srgbClr val="0F172A"/>
+                </a:solidFill>
+                <a:latin typeface="Calibri"/>
+              </a:rPr>
+              <a:t>What the contact check found — and what to verify before calling</a:t>
+            </a:r>
+          </a:p>
+        </p:txBody>
+      </p:sp>
+      <p:sp>
+        <p:nvSpPr>
+          <p:cNvPr id="5" name="Rectangle 4"/>
+          <p:cNvSpPr/>
+          <p:nvPr/>
+        </p:nvSpPr>
+        <p:spPr>
+          <a:xfrm>
+            <a:off x="548640" y="1554480"/>
+            <a:ext cx="5486400" cy="3108960"/>
+          </a:xfrm>
+          <a:prstGeom prst="rect">
+            <a:avLst/>
+          </a:prstGeom>
+          <a:solidFill>
+            <a:srgbClr val="FFFFFF"/>
+          </a:solidFill>
+          <a:ln w="12700">
+            <a:solidFill>
+              <a:srgbClr val="E2E8F0"/>
+            </a:solidFill>
+          </a:ln>
+          <a:effectLst/>
+        </p:spPr>
+        <p:style>
+          <a:lnRef idx="1">
+            <a:schemeClr val="accent1"/>
+          </a:lnRef>
+          <a:fillRef idx="3">
+            <a:schemeClr val="accent1"/>
+          </a:fillRef>
+          <a:effectRef idx="2">
+            <a:schemeClr val="accent1"/>
+          </a:effectRef>
+          <a:fontRef idx="minor">
+            <a:schemeClr val="lt1"/>
+          </a:fontRef>
+        </p:style>
+        <p:txBody>
+          <a:bodyPr rtlCol="0" anchor="ctr"/>
+          <a:lstStyle/>
+          <a:p>
+            <a:pPr algn="ctr"/>
+          </a:p>
+        </p:txBody>
+      </p:sp>
+      <p:sp>
+        <p:nvSpPr>
+          <p:cNvPr id="6" name="TextBox 5"/>
+          <p:cNvSpPr txBox="1"/>
+          <p:nvPr/>
+        </p:nvSpPr>
+        <p:spPr>
+          <a:xfrm>
+            <a:off x="777240" y="1691640"/>
+            <a:ext cx="5029200" cy="274320"/>
+          </a:xfrm>
+          <a:prstGeom prst="rect">
+            <a:avLst/>
+          </a:prstGeom>
+          <a:noFill/>
+        </p:spPr>
+        <p:txBody>
+          <a:bodyPr wrap="square" anchor="t">
+            <a:spAutoFit/>
+          </a:bodyPr>
+          <a:lstStyle/>
+          <a:p>
+            <a:pPr algn="l">
+              <a:lnSpc>
+                <a:spcPct val="105000"/>
+              </a:lnSpc>
+            </a:pPr>
+            <a:r>
+              <a:rPr sz="1100" b="1" i="0">
+                <a:solidFill>
+                  <a:srgbClr val="1A7A4A"/>
+                </a:solidFill>
+                <a:latin typeface="Calibri"/>
+              </a:rPr>
+              <a:t>CORRECTED IN THE DATA</a:t>
+            </a:r>
+          </a:p>
+        </p:txBody>
+      </p:sp>
+      <p:sp>
+        <p:nvSpPr>
+          <p:cNvPr id="7" name="TextBox 6"/>
+          <p:cNvSpPr txBox="1"/>
+          <p:nvPr/>
+        </p:nvSpPr>
+        <p:spPr>
+          <a:xfrm>
+            <a:off x="777240" y="2011680"/>
+            <a:ext cx="5029200" cy="2560320"/>
+          </a:xfrm>
+          <a:prstGeom prst="rect">
+            <a:avLst/>
+          </a:prstGeom>
+          <a:noFill/>
+        </p:spPr>
+        <p:txBody>
+          <a:bodyPr wrap="square">
+            <a:spAutoFit/>
+          </a:bodyPr>
+          <a:lstStyle/>
+          <a:p>
+            <a:pPr>
+              <a:lnSpc>
+                <a:spcPct val="110000"/>
+              </a:lnSpc>
+              <a:spcAft>
+                <a:spcPts val="600"/>
+              </a:spcAft>
+            </a:pPr>
+            <a:r>
+              <a:rPr sz="1300">
+                <a:solidFill>
+                  <a:srgbClr val="475569"/>
+                </a:solidFill>
+                <a:latin typeface="Calibri"/>
+              </a:rPr>
+              <a:t>—  Community to Community has moved: 1319 Cornwall Ave, Suite 101 (the map pin is moved).</a:t>
+            </a:r>
+          </a:p>
+          <a:p>
+            <a:pPr>
+              <a:lnSpc>
+                <a:spcPct val="110000"/>
+              </a:lnSpc>
+              <a:spcAft>
+                <a:spcPts val="600"/>
+              </a:spcAft>
+            </a:pPr>
+            <a:r>
+              <a:rPr sz="1300">
+                <a:solidFill>
+                  <a:srgbClr val="475569"/>
+                </a:solidFill>
+                <a:latin typeface="Calibri"/>
+              </a:rPr>
+              <a:t>—  Cascade Cooperatives incorporated in January 2022, not 2019; it began in 2014 as the Co-op Education Project.</a:t>
+            </a:r>
+          </a:p>
+          <a:p>
+            <a:pPr>
+              <a:lnSpc>
+                <a:spcPct val="110000"/>
+              </a:lnSpc>
+              <a:spcAft>
+                <a:spcPts val="600"/>
+              </a:spcAft>
+            </a:pPr>
+            <a:r>
+              <a:rPr sz="1300">
+                <a:solidFill>
+                  <a:srgbClr val="475569"/>
+                </a:solidFill>
+                <a:latin typeface="Calibri"/>
+              </a:rPr>
+              <a:t>—  CHS Northwest in Lynden is at 402 Main St.</a:t>
+            </a:r>
+          </a:p>
+          <a:p>
+            <a:pPr>
+              <a:lnSpc>
+                <a:spcPct val="110000"/>
+              </a:lnSpc>
+              <a:spcAft>
+                <a:spcPts val="600"/>
+              </a:spcAft>
+            </a:pPr>
+            <a:r>
+              <a:rPr sz="1300">
+                <a:solidFill>
+                  <a:srgbClr val="475569"/>
+                </a:solidFill>
+                <a:latin typeface="Calibri"/>
+              </a:rPr>
+              <a:t>—  Industrial Credit Union’s website is industrialcu.com.</a:t>
+            </a:r>
+          </a:p>
+          <a:p>
+            <a:pPr>
+              <a:lnSpc>
+                <a:spcPct val="110000"/>
+              </a:lnSpc>
+              <a:spcAft>
+                <a:spcPts val="600"/>
+              </a:spcAft>
+            </a:pPr>
+            <a:r>
+              <a:rPr sz="1300">
+                <a:solidFill>
+                  <a:srgbClr val="475569"/>
+                </a:solidFill>
+                <a:latin typeface="Calibri"/>
+              </a:rPr>
+              <a:t>—  Yellow Cab Co-op has its own site, yellowcabcoop.com.</a:t>
+            </a:r>
+          </a:p>
+        </p:txBody>
+      </p:sp>
+      <p:sp>
+        <p:nvSpPr>
+          <p:cNvPr id="8" name="Rectangle 7"/>
+          <p:cNvSpPr/>
+          <p:nvPr/>
+        </p:nvSpPr>
+        <p:spPr>
+          <a:xfrm>
+            <a:off x="6263640" y="1554480"/>
+            <a:ext cx="5394960" cy="3108960"/>
+          </a:xfrm>
+          <a:prstGeom prst="rect">
+            <a:avLst/>
+          </a:prstGeom>
+          <a:solidFill>
+            <a:srgbClr val="FEF3C7"/>
+          </a:solidFill>
+          <a:ln w="12700">
+            <a:solidFill>
+              <a:srgbClr val="FDE047"/>
+            </a:solidFill>
+          </a:ln>
+          <a:effectLst/>
+        </p:spPr>
+        <p:style>
+          <a:lnRef idx="1">
+            <a:schemeClr val="accent1"/>
+          </a:lnRef>
+          <a:fillRef idx="3">
+            <a:schemeClr val="accent1"/>
+          </a:fillRef>
+          <a:effectRef idx="2">
+            <a:schemeClr val="accent1"/>
+          </a:effectRef>
+          <a:fontRef idx="minor">
+            <a:schemeClr val="lt1"/>
+          </a:fontRef>
+        </p:style>
+        <p:txBody>
+          <a:bodyPr rtlCol="0" anchor="ctr"/>
+          <a:lstStyle/>
+          <a:p>
+            <a:pPr algn="ctr"/>
+          </a:p>
+        </p:txBody>
+      </p:sp>
+      <p:sp>
+        <p:nvSpPr>
+          <p:cNvPr id="9" name="TextBox 8"/>
+          <p:cNvSpPr txBox="1"/>
+          <p:nvPr/>
+        </p:nvSpPr>
+        <p:spPr>
+          <a:xfrm>
+            <a:off x="6492240" y="1691640"/>
+            <a:ext cx="4937760" cy="274320"/>
+          </a:xfrm>
+          <a:prstGeom prst="rect">
+            <a:avLst/>
+          </a:prstGeom>
+          <a:noFill/>
+        </p:spPr>
+        <p:txBody>
+          <a:bodyPr wrap="square" anchor="t">
+            <a:spAutoFit/>
+          </a:bodyPr>
+          <a:lstStyle/>
+          <a:p>
+            <a:pPr algn="l">
+              <a:lnSpc>
+                <a:spcPct val="105000"/>
+              </a:lnSpc>
+            </a:pPr>
+            <a:r>
+              <a:rPr sz="1100" b="1" i="0">
+                <a:solidFill>
+                  <a:srgbClr val="854D0E"/>
+                </a:solidFill>
+                <a:latin typeface="Calibri"/>
+              </a:rPr>
+              <a:t>VERIFY BEFORE RELYING ON IT</a:t>
+            </a:r>
+          </a:p>
+        </p:txBody>
+      </p:sp>
+      <p:sp>
+        <p:nvSpPr>
+          <p:cNvPr id="10" name="TextBox 9"/>
+          <p:cNvSpPr txBox="1"/>
+          <p:nvPr/>
+        </p:nvSpPr>
+        <p:spPr>
+          <a:xfrm>
+            <a:off x="6492240" y="2011680"/>
+            <a:ext cx="4937760" cy="2560320"/>
+          </a:xfrm>
+          <a:prstGeom prst="rect">
+            <a:avLst/>
+          </a:prstGeom>
+          <a:noFill/>
+        </p:spPr>
+        <p:txBody>
+          <a:bodyPr wrap="square">
+            <a:spAutoFit/>
+          </a:bodyPr>
+          <a:lstStyle/>
+          <a:p>
+            <a:pPr>
+              <a:lnSpc>
+                <a:spcPct val="110000"/>
+              </a:lnSpc>
+              <a:spcAft>
+                <a:spcPts val="600"/>
+              </a:spcAft>
+            </a:pPr>
+            <a:r>
+              <a:rPr sz="1300">
+                <a:solidFill>
+                  <a:srgbClr val="854D0E"/>
+                </a:solidFill>
+                <a:latin typeface="Calibri"/>
+              </a:rPr>
+              <a:t>—  Community Media Cooperative — media-coop.com no longer resolves; it may have closed.</a:t>
+            </a:r>
+          </a:p>
+          <a:p>
+            <a:pPr>
+              <a:lnSpc>
+                <a:spcPct val="110000"/>
+              </a:lnSpc>
+              <a:spcAft>
+                <a:spcPts val="600"/>
+              </a:spcAft>
+            </a:pPr>
+            <a:r>
+              <a:rPr sz="1300">
+                <a:solidFill>
+                  <a:srgbClr val="854D0E"/>
+                </a:solidFill>
+                <a:latin typeface="Calibri"/>
+              </a:rPr>
+              <a:t>—  Cascadia Deaf Nation — website answers “Payment Required”; it may have lapsed.</a:t>
+            </a:r>
+          </a:p>
+          <a:p>
+            <a:pPr>
+              <a:lnSpc>
+                <a:spcPct val="110000"/>
+              </a:lnSpc>
+              <a:spcAft>
+                <a:spcPts val="600"/>
+              </a:spcAft>
+            </a:pPr>
+            <a:r>
+              <a:rPr sz="1300">
+                <a:solidFill>
+                  <a:srgbClr val="854D0E"/>
+                </a:solidFill>
+                <a:latin typeface="Calibri"/>
+              </a:rPr>
+              <a:t>—  Bellingham Bay Builders — only the 2004 founders are published, not the current owner-members.</a:t>
+            </a:r>
+          </a:p>
+          <a:p>
+            <a:pPr>
+              <a:lnSpc>
+                <a:spcPct val="110000"/>
+              </a:lnSpc>
+              <a:spcAft>
+                <a:spcPts val="600"/>
+              </a:spcAft>
+            </a:pPr>
+            <a:r>
+              <a:rPr sz="1300">
+                <a:solidFill>
+                  <a:srgbClr val="854D0E"/>
+                </a:solidFill>
+                <a:latin typeface="Calibri"/>
+              </a:rPr>
+              <a:t>—  WestEdge CU, Yellow Cab Co-op, Circle of Life, CHS — no leader named on their own sites.</a:t>
+            </a:r>
+          </a:p>
+          <a:p>
+            <a:pPr>
+              <a:lnSpc>
+                <a:spcPct val="110000"/>
+              </a:lnSpc>
+              <a:spcAft>
+                <a:spcPts val="600"/>
+              </a:spcAft>
+            </a:pPr>
+            <a:r>
+              <a:rPr sz="1300">
+                <a:solidFill>
+                  <a:srgbClr val="854D0E"/>
+                </a:solidFill>
+                <a:latin typeface="Calibri"/>
+              </a:rPr>
+              <a:t>—  Tierra y Libertad — no website of its own; reach it through C2C.</a:t>
+            </a:r>
+          </a:p>
+        </p:txBody>
+      </p:sp>
+      <p:sp>
+        <p:nvSpPr>
+          <p:cNvPr id="11" name="TextBox 10"/>
+          <p:cNvSpPr txBox="1"/>
+          <p:nvPr/>
+        </p:nvSpPr>
+        <p:spPr>
+          <a:xfrm>
+            <a:off x="548640" y="4983480"/>
+            <a:ext cx="11064240" cy="731520"/>
+          </a:xfrm>
+          <a:prstGeom prst="rect">
+            <a:avLst/>
+          </a:prstGeom>
+          <a:noFill/>
+        </p:spPr>
+        <p:txBody>
+          <a:bodyPr wrap="square" anchor="t">
+            <a:spAutoFit/>
+          </a:bodyPr>
+          <a:lstStyle/>
+          <a:p>
+            <a:pPr algn="l">
+              <a:lnSpc>
+                <a:spcPct val="105000"/>
+              </a:lnSpc>
+            </a:pPr>
+            <a:r>
+              <a:rPr sz="1500" b="0" i="1">
+                <a:solidFill>
+                  <a:srgbClr val="475569"/>
+                </a:solidFill>
+                <a:latin typeface="Calibri"/>
+              </a:rPr>
+              <a:t>Every contact carries “Checked Sep 2026” and the page it was read from. Phones and names change; the date says how far to trust them.</a:t>
+            </a:r>
+          </a:p>
+        </p:txBody>
+      </p:sp>
+      <p:sp>
+        <p:nvSpPr>
+          <p:cNvPr id="12" name="TextBox 11"/>
+          <p:cNvSpPr txBox="1"/>
+          <p:nvPr/>
+        </p:nvSpPr>
+        <p:spPr>
+          <a:xfrm>
+            <a:off x="548640" y="6446520"/>
+            <a:ext cx="5486400" cy="274320"/>
+          </a:xfrm>
+          <a:prstGeom prst="rect">
+            <a:avLst/>
+          </a:prstGeom>
+          <a:noFill/>
+        </p:spPr>
+        <p:txBody>
+          <a:bodyPr wrap="square" anchor="t">
+            <a:spAutoFit/>
+          </a:bodyPr>
+          <a:lstStyle/>
+          <a:p>
+            <a:pPr algn="l">
+              <a:lnSpc>
+                <a:spcPct val="105000"/>
+              </a:lnSpc>
+            </a:pPr>
+            <a:r>
+              <a:rPr sz="900" b="0" i="0">
+                <a:solidFill>
+                  <a:srgbClr val="94A3B8"/>
+                </a:solidFill>
+                <a:latin typeface="Calibri"/>
+              </a:rPr>
+              <a:t>Co-ops of Whatcom County · RCN</a:t>
+            </a:r>
+          </a:p>
+        </p:txBody>
+      </p:sp>
+      <p:sp>
+        <p:nvSpPr>
+          <p:cNvPr id="13" name="TextBox 12"/>
+          <p:cNvSpPr txBox="1"/>
+          <p:nvPr/>
+        </p:nvSpPr>
+        <p:spPr>
+          <a:xfrm>
+            <a:off x="11247120" y="6446520"/>
+            <a:ext cx="365760" cy="274320"/>
+          </a:xfrm>
+          <a:prstGeom prst="rect">
+            <a:avLst/>
+          </a:prstGeom>
+          <a:noFill/>
+        </p:spPr>
+        <p:txBody>
+          <a:bodyPr wrap="square" anchor="t">
+            <a:spAutoFit/>
+          </a:bodyPr>
+          <a:lstStyle/>
+          <a:p>
+            <a:pPr algn="r">
+              <a:lnSpc>
+                <a:spcPct val="105000"/>
+              </a:lnSpc>
+            </a:pPr>
+            <a:r>
+              <a:rPr sz="900" b="0" i="0">
+                <a:solidFill>
+                  <a:srgbClr val="94A3B8"/>
+                </a:solidFill>
+                <a:latin typeface="Calibri"/>
+              </a:rPr>
+              <a:t>18</a:t>
+            </a:r>
+          </a:p>
+        </p:txBody>
+      </p:sp>
+    </p:spTree>
+  </p:cSld>
+  <p:clrMapOvr>
+    <a:masterClrMapping/>
+  </p:clrMapOvr>
+</p:sld>
+</file>
+
+<file path=ppt/slides/slide19.xml><?xml version="1.0" encoding="utf-8"?>
 <p:sld xmlns:a="http://schemas.openxmlformats.org/drawingml/2006/main" xmlns:p="http://schemas.openxmlformats.org/presentationml/2006/main" xmlns:r="http://schemas.openxmlformats.org/officeDocument/2006/relationships">
   <p:cSld>
     <p:bg>
@@ -7458,7 +8489,7 @@
                 </a:solidFill>
                 <a:latin typeface="Calibri"/>
               </a:rPr>
-              <a:t>—  FedWiki: drag docs/whatcom-coops-wiki/whatcom-coops-wiki.json onto any lineup; upload the rcn-table folder for the table.</a:t>
+              <a:t>—  FedWiki: drag docs/whatcom-coops-wiki/whatcom-coops-wiki.json onto a lineup on a wiki with the RCN Map and RCN Timeline plugins; “Open in RCN Timeline” opens any page’s timeline in the full tool.</a:t>
             </a:r>
           </a:p>
           <a:p>
@@ -8688,7 +9719,7 @@
                 </a:solidFill>
                 <a:latin typeface="Calibri"/>
               </a:rPr>
-              <a:t>—  FedWiki — one page per co-op: its record, its graph, a map, its website; the table plugin on the index page.</a:t>
+              <a:t>—  FedWiki — one page per co-op: its record, its graph, its map with ties, its timeline, its website; the table plugin on the index page.</a:t>
             </a:r>
           </a:p>
         </p:txBody>

</xml_diff>

<commit_message>
Timeline: text always on top; deck slide of wiki pages with timelines
- rcn-timeline.html draws in layers: links, bars, the selected bar's
  handles, then all text (bar labels and relation labels), then the
  date axis. Labels used to sit in each bar's own group, so later bars
  and links could cover earlier labels; handles covered their own bar's
  label. Labels keep their bar's press, drag and tooltip. Verified by
  hit-testing visible labels; 22 solver tests pass.
- Deck (20 slides): new slide of two co-op pages side by side in the
  wiki, each with its map and timeline.

Co-Authored-By: Claude Opus 5.5 <noreply@anthropic.com>
</commit_message>
<xml_diff>
--- a/docs/whatcom-coops-four-lenses.pptx
+++ b/docs/whatcom-coops-four-lenses.pptx
@@ -24,6 +24,7 @@
     <p:sldId id="272" r:id="rId23"/>
     <p:sldId id="273" r:id="rId24"/>
     <p:sldId id="274" r:id="rId25"/>
+    <p:sldId id="275" r:id="rId26"/>
   </p:sldIdLst>
   <p:sldSz cx="12188952" cy="6858000" type="screen4x3"/>
   <p:notesSz cx="6858000" cy="9144000"/>
@@ -6120,7 +6121,7 @@
                 </a:solidFill>
                 <a:latin typeface="Calibri"/>
               </a:rPr>
-              <a:t>FEDWIKI — OPEN IN RCN TIMELINE</a:t>
+              <a:t>FEDWIKI — PAGES WITH TIMELINES</a:t>
             </a:r>
           </a:p>
         </p:txBody>
@@ -6159,7 +6160,7 @@
                 </a:solidFill>
                 <a:latin typeface="Calibri"/>
               </a:rPr>
-              <a:t>One click from the page to the full Timeline tool</a:t>
+              <a:t>Two co-op pages side by side, each with its map and its history</a:t>
             </a:r>
           </a:p>
         </p:txBody>
@@ -6173,7 +6174,7 @@
         <p:spPr>
           <a:xfrm>
             <a:off x="521207" y="1453896"/>
-            <a:ext cx="6380338" cy="4672583"/>
+            <a:ext cx="5139857" cy="4718303"/>
           </a:xfrm>
           <a:prstGeom prst="rect">
             <a:avLst/>
@@ -6210,7 +6211,7 @@
       </p:sp>
       <p:pic>
         <p:nvPicPr>
-          <p:cNvPr id="6" name="Picture 5" descr="15-timeline-tool-opened.jpg"/>
+          <p:cNvPr id="6" name="Picture 5" descr="17-wiki-lineup-timelines.jpg"/>
           <p:cNvPicPr>
             <a:picLocks noChangeAspect="1"/>
           </p:cNvPicPr>
@@ -6225,7 +6226,7 @@
         <p:spPr>
           <a:xfrm>
             <a:off x="548640" y="1481328"/>
-            <a:ext cx="6325474" cy="4617720"/>
+            <a:ext cx="5084993" cy="4663440"/>
           </a:xfrm>
           <a:prstGeom prst="rect">
             <a:avLst/>
@@ -6240,8 +6241,8 @@
         </p:nvSpPr>
         <p:spPr>
           <a:xfrm>
-            <a:off x="8869680" y="1481328"/>
-            <a:ext cx="2926080" cy="274320"/>
+            <a:off x="6126480" y="1481328"/>
+            <a:ext cx="5486400" cy="274320"/>
           </a:xfrm>
           <a:prstGeom prst="rect">
             <a:avLst/>
@@ -6279,8 +6280,8 @@
         </p:nvSpPr>
         <p:spPr>
           <a:xfrm>
-            <a:off x="8869680" y="1810512"/>
-            <a:ext cx="2834640" cy="4206240"/>
+            <a:off x="6126480" y="1810512"/>
+            <a:ext cx="5486400" cy="4480560"/>
           </a:xfrm>
           <a:prstGeom prst="rect">
             <a:avLst/>
@@ -6298,7 +6299,7 @@
                 <a:spcPct val="110000"/>
               </a:lnSpc>
               <a:spcAft>
-                <a:spcPts val="800"/>
+                <a:spcPts val="600"/>
               </a:spcAft>
             </a:pPr>
             <a:r>
@@ -6308,7 +6309,7 @@
                 </a:solidFill>
                 <a:latin typeface="Calibri"/>
               </a:rPr>
-              <a:t>—  “Open in RCN Timeline ↗” under any timeline opens the full tool in its own tab, with that timeline loaded: the North Cascades Meat co-op’s 8 intervals here.</a:t>
+              <a:t>—  Left: Cascade Cooperatives, the network. Its map fans out to its 13 members; its timeline puts the network’s own start (2014, renamed 2019) above each member’s history — the credit unions of the 1930s–50s, the worker co-ops of the 2000s and 2020s.</a:t>
             </a:r>
           </a:p>
           <a:p>
@@ -6317,7 +6318,7 @@
                 <a:spcPct val="110000"/>
               </a:lnSpc>
               <a:spcAft>
-                <a:spcPts val="800"/>
+                <a:spcPts val="600"/>
               </a:spcAft>
             </a:pPr>
             <a:r>
@@ -6327,7 +6328,7 @@
                 </a:solidFill>
                 <a:latin typeface="Calibri"/>
               </a:rPr>
-              <a:t>—  Nothing is lost on the way: the bar’s page and co-op links ride along, so the tool can hand them back.</a:t>
+              <a:t>—  Right: Community to Community (C2C). Its map shows the Food Co-op’s grant and the farmworker co-op it incubated; its timeline shows the grant falling inside C2C’s years, and Tierra y Libertad starting in 2017.</a:t>
             </a:r>
           </a:p>
           <a:p>
@@ -6336,7 +6337,7 @@
                 <a:spcPct val="110000"/>
               </a:lnSpc>
               <a:spcAft>
-                <a:spcPts val="800"/>
+                <a:spcPts val="600"/>
               </a:spcAft>
             </a:pPr>
             <a:r>
@@ -6346,7 +6347,7 @@
                 </a:solidFill>
                 <a:latin typeface="Calibri"/>
               </a:rPr>
-              <a:t>—  Open a second timeline from another page and the same tab switches to it, as one undo step.</a:t>
+              <a:t>—  Each page is an ordinary FedWiki page in a lineup: click any bar or point and that co-op’s page opens to the right.</a:t>
             </a:r>
           </a:p>
           <a:p>
@@ -6355,7 +6356,7 @@
                 <a:spcPct val="110000"/>
               </a:lnSpc>
               <a:spcAft>
-                <a:spcPts val="800"/>
+                <a:spcPts val="600"/>
               </a:spcAft>
             </a:pPr>
             <a:r>
@@ -6365,7 +6366,7 @@
                 </a:solidFill>
                 <a:latin typeface="Calibri"/>
               </a:rPr>
-              <a:t>—  Edits made in the tool do not come back to the page yet — saving back is the next step.</a:t>
+              <a:t>—  Under each timeline, Open in RCN Timeline ↗ takes it into the full tool.</a:t>
             </a:r>
           </a:p>
         </p:txBody>
@@ -6378,8 +6379,8 @@
         </p:nvSpPr>
         <p:spPr>
           <a:xfrm>
-            <a:off x="548640" y="6190488"/>
-            <a:ext cx="8001000" cy="274320"/>
+            <a:off x="548640" y="6236207"/>
+            <a:ext cx="7315200" cy="274320"/>
           </a:xfrm>
           <a:prstGeom prst="rect">
             <a:avLst/>
@@ -6404,7 +6405,7 @@
                 </a:solidFill>
                 <a:latin typeface="Calibri"/>
               </a:rPr>
-              <a:t>Screenshot · RCN Timeline, opened from the North Cascades Meat Producers Cooperative page</a:t>
+              <a:t>Screenshot · local wiki coops.localhost, Cascade Cooperatives and Community to Community C2C</a:t>
             </a:r>
           </a:p>
         </p:txBody>
@@ -6591,7 +6592,7 @@
                 </a:solidFill>
                 <a:latin typeface="Calibri"/>
               </a:rPr>
-              <a:t>FEDWIKI — TABLE PLUGIN</a:t>
+              <a:t>FEDWIKI — OPEN IN RCN TIMELINE</a:t>
             </a:r>
           </a:p>
         </p:txBody>
@@ -6630,7 +6631,7 @@
                 </a:solidFill>
                 <a:latin typeface="Calibri"/>
               </a:rPr>
-              <a:t>The FedWiki table plugin: all 22 co-ops on the index page</a:t>
+              <a:t>One click from the page to the full Timeline tool</a:t>
             </a:r>
           </a:p>
         </p:txBody>
@@ -6644,7 +6645,7 @@
         <p:spPr>
           <a:xfrm>
             <a:off x="521207" y="1453896"/>
-            <a:ext cx="3255264" cy="2138845"/>
+            <a:ext cx="6380338" cy="4672583"/>
           </a:xfrm>
           <a:prstGeom prst="rect">
             <a:avLst/>
@@ -6681,7 +6682,7 @@
       </p:sp>
       <p:pic>
         <p:nvPicPr>
-          <p:cNvPr id="6" name="Picture 5" descr="12-wiki-table-item.jpg"/>
+          <p:cNvPr id="6" name="Picture 5" descr="15-timeline-tool-opened.jpg"/>
           <p:cNvPicPr>
             <a:picLocks noChangeAspect="1"/>
           </p:cNvPicPr>
@@ -6696,7 +6697,7 @@
         <p:spPr>
           <a:xfrm>
             <a:off x="548640" y="1481328"/>
-            <a:ext cx="3200400" cy="2083981"/>
+            <a:ext cx="6325474" cy="4617720"/>
           </a:xfrm>
           <a:prstGeom prst="rect">
             <a:avLst/>
@@ -6711,8 +6712,8 @@
         </p:nvSpPr>
         <p:spPr>
           <a:xfrm>
-            <a:off x="548640" y="3638461"/>
-            <a:ext cx="3840480" cy="274320"/>
+            <a:off x="8869680" y="1481328"/>
+            <a:ext cx="2926080" cy="274320"/>
           </a:xfrm>
           <a:prstGeom prst="rect">
             <a:avLst/>
@@ -6731,226 +6732,158 @@
               </a:lnSpc>
             </a:pPr>
             <a:r>
+              <a:rPr sz="1100" b="1" i="0">
+                <a:solidFill>
+                  <a:srgbClr val="B45309"/>
+                </a:solidFill>
+                <a:latin typeface="Calibri"/>
+              </a:rPr>
+              <a:t>WHAT YOU ARE SEEING</a:t>
+            </a:r>
+          </a:p>
+        </p:txBody>
+      </p:sp>
+      <p:sp>
+        <p:nvSpPr>
+          <p:cNvPr id="8" name="TextBox 7"/>
+          <p:cNvSpPr txBox="1"/>
+          <p:nvPr/>
+        </p:nvSpPr>
+        <p:spPr>
+          <a:xfrm>
+            <a:off x="8869680" y="1810512"/>
+            <a:ext cx="2834640" cy="4206240"/>
+          </a:xfrm>
+          <a:prstGeom prst="rect">
+            <a:avLst/>
+          </a:prstGeom>
+          <a:noFill/>
+        </p:spPr>
+        <p:txBody>
+          <a:bodyPr wrap="square">
+            <a:spAutoFit/>
+          </a:bodyPr>
+          <a:lstStyle/>
+          <a:p>
+            <a:pPr>
+              <a:lnSpc>
+                <a:spcPct val="110000"/>
+              </a:lnSpc>
+              <a:spcAft>
+                <a:spcPts val="800"/>
+              </a:spcAft>
+            </a:pPr>
+            <a:r>
+              <a:rPr sz="1400">
+                <a:solidFill>
+                  <a:srgbClr val="475569"/>
+                </a:solidFill>
+                <a:latin typeface="Calibri"/>
+              </a:rPr>
+              <a:t>—  “Open in RCN Timeline ↗” under any timeline opens the full tool in its own tab, with that timeline loaded: the North Cascades Meat co-op’s 8 intervals here.</a:t>
+            </a:r>
+          </a:p>
+          <a:p>
+            <a:pPr>
+              <a:lnSpc>
+                <a:spcPct val="110000"/>
+              </a:lnSpc>
+              <a:spcAft>
+                <a:spcPts val="800"/>
+              </a:spcAft>
+            </a:pPr>
+            <a:r>
+              <a:rPr sz="1400">
+                <a:solidFill>
+                  <a:srgbClr val="475569"/>
+                </a:solidFill>
+                <a:latin typeface="Calibri"/>
+              </a:rPr>
+              <a:t>—  Nothing is lost on the way: the bar’s page and co-op links ride along, so the tool can hand them back.</a:t>
+            </a:r>
+          </a:p>
+          <a:p>
+            <a:pPr>
+              <a:lnSpc>
+                <a:spcPct val="110000"/>
+              </a:lnSpc>
+              <a:spcAft>
+                <a:spcPts val="800"/>
+              </a:spcAft>
+            </a:pPr>
+            <a:r>
+              <a:rPr sz="1400">
+                <a:solidFill>
+                  <a:srgbClr val="475569"/>
+                </a:solidFill>
+                <a:latin typeface="Calibri"/>
+              </a:rPr>
+              <a:t>—  Open a second timeline from another page and the same tab switches to it, as one undo step.</a:t>
+            </a:r>
+          </a:p>
+          <a:p>
+            <a:pPr>
+              <a:lnSpc>
+                <a:spcPct val="110000"/>
+              </a:lnSpc>
+              <a:spcAft>
+                <a:spcPts val="800"/>
+              </a:spcAft>
+            </a:pPr>
+            <a:r>
+              <a:rPr sz="1400">
+                <a:solidFill>
+                  <a:srgbClr val="475569"/>
+                </a:solidFill>
+                <a:latin typeface="Calibri"/>
+              </a:rPr>
+              <a:t>—  Edits made in the tool do not come back to the page yet — saving back is the next step.</a:t>
+            </a:r>
+          </a:p>
+        </p:txBody>
+      </p:sp>
+      <p:sp>
+        <p:nvSpPr>
+          <p:cNvPr id="9" name="TextBox 8"/>
+          <p:cNvSpPr txBox="1"/>
+          <p:nvPr/>
+        </p:nvSpPr>
+        <p:spPr>
+          <a:xfrm>
+            <a:off x="548640" y="6190488"/>
+            <a:ext cx="8001000" cy="274320"/>
+          </a:xfrm>
+          <a:prstGeom prst="rect">
+            <a:avLst/>
+          </a:prstGeom>
+          <a:noFill/>
+        </p:spPr>
+        <p:txBody>
+          <a:bodyPr wrap="square" anchor="t">
+            <a:spAutoFit/>
+          </a:bodyPr>
+          <a:lstStyle/>
+          <a:p>
+            <a:pPr algn="l">
+              <a:lnSpc>
+                <a:spcPct val="105000"/>
+              </a:lnSpc>
+            </a:pPr>
+            <a:r>
               <a:rPr sz="1000" b="0" i="1">
                 <a:solidFill>
                   <a:srgbClr val="94A3B8"/>
                 </a:solidFill>
                 <a:latin typeface="Calibri"/>
               </a:rPr>
-              <a:t>The rcntable item on the index page</a:t>
-            </a:r>
-          </a:p>
-        </p:txBody>
-      </p:sp>
-      <p:sp>
-        <p:nvSpPr>
-          <p:cNvPr id="8" name="TextBox 7"/>
-          <p:cNvSpPr txBox="1"/>
-          <p:nvPr/>
-        </p:nvSpPr>
-        <p:spPr>
-          <a:xfrm>
-            <a:off x="548640" y="3976789"/>
-            <a:ext cx="3931920" cy="2651760"/>
-          </a:xfrm>
-          <a:prstGeom prst="rect">
-            <a:avLst/>
-          </a:prstGeom>
-          <a:noFill/>
-        </p:spPr>
-        <p:txBody>
-          <a:bodyPr wrap="square">
-            <a:spAutoFit/>
-          </a:bodyPr>
-          <a:lstStyle/>
-          <a:p>
-            <a:pPr>
-              <a:lnSpc>
-                <a:spcPct val="110000"/>
-              </a:lnSpc>
-              <a:spcAft>
-                <a:spcPts val="300"/>
-              </a:spcAft>
-            </a:pPr>
-            <a:r>
-              <a:rPr sz="1200">
-                <a:solidFill>
-                  <a:srgbClr val="475569"/>
-                </a:solidFill>
-                <a:latin typeface="Calibri"/>
-              </a:rPr>
-              <a:t>—  The item names the records: database whatcomcoops, kind Coop.</a:t>
-            </a:r>
-          </a:p>
-          <a:p>
-            <a:pPr>
-              <a:lnSpc>
-                <a:spcPct val="110000"/>
-              </a:lnSpc>
-              <a:spcAft>
-                <a:spcPts val="300"/>
-              </a:spcAft>
-            </a:pPr>
-            <a:r>
-              <a:rPr sz="1200">
-                <a:solidFill>
-                  <a:srgbClr val="475569"/>
-                </a:solidFill>
-                <a:latin typeface="Calibri"/>
-              </a:rPr>
-              <a:t>—  Open Table ↗ opens the RCN Table beside the wiki — the same table as slide 9.</a:t>
-            </a:r>
-          </a:p>
-          <a:p>
-            <a:pPr>
-              <a:lnSpc>
-                <a:spcPct val="110000"/>
-              </a:lnSpc>
-              <a:spcAft>
-                <a:spcPts val="300"/>
-              </a:spcAft>
-            </a:pPr>
-            <a:r>
-              <a:rPr sz="1200">
-                <a:solidFill>
-                  <a:srgbClr val="475569"/>
-                </a:solidFill>
-                <a:latin typeface="Calibri"/>
-              </a:rPr>
-              <a:t>—  At home it reads Neo4j live through substrate/api.py. On a hosted wiki it reads the exported folder in the site’s own assets, so each site is its own database.</a:t>
-            </a:r>
-          </a:p>
-          <a:p>
-            <a:pPr>
-              <a:lnSpc>
-                <a:spcPct val="110000"/>
-              </a:lnSpc>
-              <a:spcAft>
-                <a:spcPts val="300"/>
-              </a:spcAft>
-            </a:pPr>
-            <a:r>
-              <a:rPr sz="1200">
-                <a:solidFill>
-                  <a:srgbClr val="475569"/>
-                </a:solidFill>
-                <a:latin typeface="Calibri"/>
-              </a:rPr>
-              <a:t>—  Every name in the table opens that co-op’s page in the lineup.</a:t>
-            </a:r>
-          </a:p>
-        </p:txBody>
-      </p:sp>
-      <p:sp>
-        <p:nvSpPr>
-          <p:cNvPr id="9" name="Rectangle 8"/>
-          <p:cNvSpPr/>
-          <p:nvPr/>
-        </p:nvSpPr>
-        <p:spPr>
-          <a:xfrm>
-            <a:off x="4727448" y="1453896"/>
-            <a:ext cx="6912864" cy="4068451"/>
-          </a:xfrm>
-          <a:prstGeom prst="rect">
-            <a:avLst/>
-          </a:prstGeom>
-          <a:solidFill>
-            <a:srgbClr val="E2E8F0"/>
-          </a:solidFill>
-          <a:ln>
-            <a:noFill/>
-          </a:ln>
-          <a:effectLst/>
-        </p:spPr>
-        <p:style>
-          <a:lnRef idx="1">
-            <a:schemeClr val="accent1"/>
-          </a:lnRef>
-          <a:fillRef idx="3">
-            <a:schemeClr val="accent1"/>
-          </a:fillRef>
-          <a:effectRef idx="2">
-            <a:schemeClr val="accent1"/>
-          </a:effectRef>
-          <a:fontRef idx="minor">
-            <a:schemeClr val="lt1"/>
-          </a:fontRef>
-        </p:style>
-        <p:txBody>
-          <a:bodyPr rtlCol="0" anchor="ctr"/>
-          <a:lstStyle/>
-          <a:p>
-            <a:pPr algn="ctr"/>
-          </a:p>
-        </p:txBody>
-      </p:sp>
-      <p:pic>
-        <p:nvPicPr>
-          <p:cNvPr id="10" name="Picture 9" descr="07-table.jpg"/>
-          <p:cNvPicPr>
-            <a:picLocks noChangeAspect="1"/>
-          </p:cNvPicPr>
-          <p:nvPr/>
-        </p:nvPicPr>
-        <p:blipFill>
-          <a:blip r:embed="rId3"/>
-          <a:stretch>
-            <a:fillRect/>
-          </a:stretch>
-        </p:blipFill>
-        <p:spPr>
-          <a:xfrm>
-            <a:off x="4754880" y="1481328"/>
-            <a:ext cx="6858000" cy="4013587"/>
-          </a:xfrm>
-          <a:prstGeom prst="rect">
-            <a:avLst/>
-          </a:prstGeom>
-        </p:spPr>
-      </p:pic>
-      <p:sp>
-        <p:nvSpPr>
-          <p:cNvPr id="11" name="TextBox 10"/>
-          <p:cNvSpPr txBox="1"/>
-          <p:nvPr/>
-        </p:nvSpPr>
-        <p:spPr>
-          <a:xfrm>
-            <a:off x="4754880" y="5568067"/>
-            <a:ext cx="6858000" cy="274320"/>
-          </a:xfrm>
-          <a:prstGeom prst="rect">
-            <a:avLst/>
-          </a:prstGeom>
-          <a:noFill/>
-        </p:spPr>
-        <p:txBody>
-          <a:bodyPr wrap="square" anchor="t">
-            <a:spAutoFit/>
-          </a:bodyPr>
-          <a:lstStyle/>
-          <a:p>
-            <a:pPr algn="l">
-              <a:lnSpc>
-                <a:spcPct val="105000"/>
-              </a:lnSpc>
-            </a:pPr>
-            <a:r>
-              <a:rPr sz="1000" b="0" i="1">
-                <a:solidFill>
-                  <a:srgbClr val="94A3B8"/>
-                </a:solidFill>
-                <a:latin typeface="Calibri"/>
-              </a:rPr>
-              <a:t>What Open Table shows</a:t>
-            </a:r>
-          </a:p>
-        </p:txBody>
-      </p:sp>
-      <p:sp>
-        <p:nvSpPr>
-          <p:cNvPr id="12" name="TextBox 11"/>
+              <a:t>Screenshot · RCN Timeline, opened from the North Cascades Meat Producers Cooperative page</a:t>
+            </a:r>
+          </a:p>
+        </p:txBody>
+      </p:sp>
+      <p:sp>
+        <p:nvSpPr>
+          <p:cNvPr id="10" name="TextBox 9"/>
           <p:cNvSpPr txBox="1"/>
           <p:nvPr/>
         </p:nvSpPr>
@@ -6989,7 +6922,7 @@
       </p:sp>
       <p:sp>
         <p:nvSpPr>
-          <p:cNvPr id="13" name="TextBox 12"/>
+          <p:cNvPr id="11" name="TextBox 10"/>
           <p:cNvSpPr txBox="1"/>
           <p:nvPr/>
         </p:nvSpPr>
@@ -7130,7 +7063,7 @@
                 </a:solidFill>
                 <a:latin typeface="Calibri"/>
               </a:rPr>
-              <a:t>FEDWIKI — HOW IT WENT</a:t>
+              <a:t>FEDWIKI — TABLE PLUGIN</a:t>
             </a:r>
           </a:p>
         </p:txBody>
@@ -7169,7 +7102,7 @@
                 </a:solidFill>
                 <a:latin typeface="Calibri"/>
               </a:rPr>
-              <a:t>Making it work: what broke, and what it cannot do</a:t>
+              <a:t>The FedWiki table plugin: all 22 co-ops on the index page</a:t>
             </a:r>
           </a:p>
         </p:txBody>
@@ -7182,19 +7115,17 @@
         </p:nvSpPr>
         <p:spPr>
           <a:xfrm>
-            <a:off x="548640" y="1554480"/>
-            <a:ext cx="5486400" cy="3429000"/>
+            <a:off x="521207" y="1453896"/>
+            <a:ext cx="3255264" cy="2138845"/>
           </a:xfrm>
           <a:prstGeom prst="rect">
             <a:avLst/>
           </a:prstGeom>
           <a:solidFill>
-            <a:srgbClr val="FFFFFF"/>
+            <a:srgbClr val="E2E8F0"/>
           </a:solidFill>
-          <a:ln w="12700">
-            <a:solidFill>
-              <a:srgbClr val="E2E8F0"/>
-            </a:solidFill>
+          <a:ln>
+            <a:noFill/>
           </a:ln>
           <a:effectLst/>
         </p:spPr>
@@ -7220,16 +7151,40 @@
           </a:p>
         </p:txBody>
       </p:sp>
-      <p:sp>
-        <p:nvSpPr>
-          <p:cNvPr id="6" name="TextBox 5"/>
-          <p:cNvSpPr txBox="1"/>
-          <p:nvPr/>
-        </p:nvSpPr>
-        <p:spPr>
-          <a:xfrm>
-            <a:off x="777240" y="1691640"/>
-            <a:ext cx="5029200" cy="274320"/>
+      <p:pic>
+        <p:nvPicPr>
+          <p:cNvPr id="6" name="Picture 5" descr="12-wiki-table-item.jpg"/>
+          <p:cNvPicPr>
+            <a:picLocks noChangeAspect="1"/>
+          </p:cNvPicPr>
+          <p:nvPr/>
+        </p:nvPicPr>
+        <p:blipFill>
+          <a:blip r:embed="rId2"/>
+          <a:stretch>
+            <a:fillRect/>
+          </a:stretch>
+        </p:blipFill>
+        <p:spPr>
+          <a:xfrm>
+            <a:off x="548640" y="1481328"/>
+            <a:ext cx="3200400" cy="2083981"/>
+          </a:xfrm>
+          <a:prstGeom prst="rect">
+            <a:avLst/>
+          </a:prstGeom>
+        </p:spPr>
+      </p:pic>
+      <p:sp>
+        <p:nvSpPr>
+          <p:cNvPr id="7" name="TextBox 6"/>
+          <p:cNvSpPr txBox="1"/>
+          <p:nvPr/>
+        </p:nvSpPr>
+        <p:spPr>
+          <a:xfrm>
+            <a:off x="548640" y="3638461"/>
+            <a:ext cx="3840480" cy="274320"/>
           </a:xfrm>
           <a:prstGeom prst="rect">
             <a:avLst/>
@@ -7248,27 +7203,27 @@
               </a:lnSpc>
             </a:pPr>
             <a:r>
-              <a:rPr sz="1100" b="1" i="0">
-                <a:solidFill>
-                  <a:srgbClr val="1A7A4A"/>
-                </a:solidFill>
-                <a:latin typeface="Calibri"/>
-              </a:rPr>
-              <a:t>FIXED</a:t>
-            </a:r>
-          </a:p>
-        </p:txBody>
-      </p:sp>
-      <p:sp>
-        <p:nvSpPr>
-          <p:cNvPr id="7" name="TextBox 6"/>
-          <p:cNvSpPr txBox="1"/>
-          <p:nvPr/>
-        </p:nvSpPr>
-        <p:spPr>
-          <a:xfrm>
-            <a:off x="777240" y="2011680"/>
-            <a:ext cx="5029200" cy="2468880"/>
+              <a:rPr sz="1000" b="0" i="1">
+                <a:solidFill>
+                  <a:srgbClr val="94A3B8"/>
+                </a:solidFill>
+                <a:latin typeface="Calibri"/>
+              </a:rPr>
+              <a:t>The rcntable item on the index page</a:t>
+            </a:r>
+          </a:p>
+        </p:txBody>
+      </p:sp>
+      <p:sp>
+        <p:nvSpPr>
+          <p:cNvPr id="8" name="TextBox 7"/>
+          <p:cNvSpPr txBox="1"/>
+          <p:nvPr/>
+        </p:nvSpPr>
+        <p:spPr>
+          <a:xfrm>
+            <a:off x="548640" y="3976789"/>
+            <a:ext cx="3931920" cy="2651760"/>
           </a:xfrm>
           <a:prstGeom prst="rect">
             <a:avLst/>
@@ -7286,17 +7241,17 @@
                 <a:spcPct val="110000"/>
               </a:lnSpc>
               <a:spcAft>
-                <a:spcPts val="600"/>
+                <a:spcPts val="300"/>
               </a:spcAft>
             </a:pPr>
             <a:r>
-              <a:rPr sz="1300">
+              <a:rPr sz="1200">
                 <a:solidFill>
                   <a:srgbClr val="475569"/>
                 </a:solidFill>
                 <a:latin typeface="Calibri"/>
               </a:rPr>
-              <a:t>—  Clicking a two-line name in a graph did nothing, or reloaded the wiki. Each co-op box is now one link. The real fix belongs in the Graph Tool, for every diagram.</a:t>
+              <a:t>—  The item names the records: database whatcomcoops, kind Coop.</a:t>
             </a:r>
           </a:p>
           <a:p>
@@ -7305,17 +7260,17 @@
                 <a:spcPct val="110000"/>
               </a:lnSpc>
               <a:spcAft>
-                <a:spcPts val="600"/>
+                <a:spcPts val="300"/>
               </a:spcAft>
             </a:pPr>
             <a:r>
-              <a:rPr sz="1300">
+              <a:rPr sz="1200">
                 <a:solidFill>
                   <a:srgbClr val="475569"/>
                 </a:solidFill>
                 <a:latin typeface="Calibri"/>
               </a:rPr>
-              <a:t>—  Maps first ran inside Frame items, which tied pages to one wiki. Two plugins of our own replaced them — RCN Map and RCN Timeline — and Frame is kept for websites only.</a:t>
+              <a:t>—  Open Table ↗ opens the RCN Table beside the wiki — the same table as slide 9.</a:t>
             </a:r>
           </a:p>
           <a:p>
@@ -7324,17 +7279,17 @@
                 <a:spcPct val="110000"/>
               </a:lnSpc>
               <a:spcAft>
-                <a:spcPts val="600"/>
+                <a:spcPts val="300"/>
               </a:spcAft>
             </a:pPr>
             <a:r>
-              <a:rPr sz="1300">
+              <a:rPr sz="1200">
                 <a:solidFill>
                   <a:srgbClr val="475569"/>
                 </a:solidFill>
                 <a:latin typeface="Calibri"/>
               </a:rPr>
-              <a:t>—  Timeline labels ran over each other in a narrow column. They now stop where the next begins, in the page and in the full tool.</a:t>
+              <a:t>—  At home it reads Neo4j live through substrate/api.py. On a hosted wiki it reads the exported folder in the site’s own assets, so each site is its own database.</a:t>
             </a:r>
           </a:p>
           <a:p>
@@ -7343,42 +7298,40 @@
                 <a:spcPct val="110000"/>
               </a:lnSpc>
               <a:spcAft>
-                <a:spcPts val="600"/>
+                <a:spcPts val="300"/>
               </a:spcAft>
             </a:pPr>
             <a:r>
-              <a:rPr sz="1300">
+              <a:rPr sz="1200">
                 <a:solidFill>
                   <a:srgbClr val="475569"/>
                 </a:solidFill>
                 <a:latin typeface="Calibri"/>
               </a:rPr>
-              <a:t>—  The Timeline tool dropped fields it did not know, so a co-op link vanished on save; and a second “Open” left it on the first timeline. Both fixed.</a:t>
-            </a:r>
-          </a:p>
-        </p:txBody>
-      </p:sp>
-      <p:sp>
-        <p:nvSpPr>
-          <p:cNvPr id="8" name="Rectangle 7"/>
+              <a:t>—  Every name in the table opens that co-op’s page in the lineup.</a:t>
+            </a:r>
+          </a:p>
+        </p:txBody>
+      </p:sp>
+      <p:sp>
+        <p:nvSpPr>
+          <p:cNvPr id="9" name="Rectangle 8"/>
           <p:cNvSpPr/>
           <p:nvPr/>
         </p:nvSpPr>
         <p:spPr>
           <a:xfrm>
-            <a:off x="6263640" y="1554480"/>
-            <a:ext cx="5394960" cy="3429000"/>
+            <a:off x="4727448" y="1453896"/>
+            <a:ext cx="6912864" cy="4068451"/>
           </a:xfrm>
           <a:prstGeom prst="rect">
             <a:avLst/>
           </a:prstGeom>
           <a:solidFill>
-            <a:srgbClr val="FEF3C7"/>
+            <a:srgbClr val="E2E8F0"/>
           </a:solidFill>
-          <a:ln w="12700">
-            <a:solidFill>
-              <a:srgbClr val="FDE047"/>
-            </a:solidFill>
+          <a:ln>
+            <a:noFill/>
           </a:ln>
           <a:effectLst/>
         </p:spPr>
@@ -7404,16 +7357,40 @@
           </a:p>
         </p:txBody>
       </p:sp>
-      <p:sp>
-        <p:nvSpPr>
-          <p:cNvPr id="9" name="TextBox 8"/>
-          <p:cNvSpPr txBox="1"/>
-          <p:nvPr/>
-        </p:nvSpPr>
-        <p:spPr>
-          <a:xfrm>
-            <a:off x="6492240" y="1691640"/>
-            <a:ext cx="4937760" cy="274320"/>
+      <p:pic>
+        <p:nvPicPr>
+          <p:cNvPr id="10" name="Picture 9" descr="07-table.jpg"/>
+          <p:cNvPicPr>
+            <a:picLocks noChangeAspect="1"/>
+          </p:cNvPicPr>
+          <p:nvPr/>
+        </p:nvPicPr>
+        <p:blipFill>
+          <a:blip r:embed="rId3"/>
+          <a:stretch>
+            <a:fillRect/>
+          </a:stretch>
+        </p:blipFill>
+        <p:spPr>
+          <a:xfrm>
+            <a:off x="4754880" y="1481328"/>
+            <a:ext cx="6858000" cy="4013587"/>
+          </a:xfrm>
+          <a:prstGeom prst="rect">
+            <a:avLst/>
+          </a:prstGeom>
+        </p:spPr>
+      </p:pic>
+      <p:sp>
+        <p:nvSpPr>
+          <p:cNvPr id="11" name="TextBox 10"/>
+          <p:cNvSpPr txBox="1"/>
+          <p:nvPr/>
+        </p:nvSpPr>
+        <p:spPr>
+          <a:xfrm>
+            <a:off x="4754880" y="5568067"/>
+            <a:ext cx="6858000" cy="274320"/>
           </a:xfrm>
           <a:prstGeom prst="rect">
             <a:avLst/>
@@ -7432,132 +7409,13 @@
               </a:lnSpc>
             </a:pPr>
             <a:r>
-              <a:rPr sz="1100" b="1" i="0">
-                <a:solidFill>
-                  <a:srgbClr val="854D0E"/>
-                </a:solidFill>
-                <a:latin typeface="Calibri"/>
-              </a:rPr>
-              <a:t>LIMITS</a:t>
-            </a:r>
-          </a:p>
-        </p:txBody>
-      </p:sp>
-      <p:sp>
-        <p:nvSpPr>
-          <p:cNvPr id="10" name="TextBox 9"/>
-          <p:cNvSpPr txBox="1"/>
-          <p:nvPr/>
-        </p:nvSpPr>
-        <p:spPr>
-          <a:xfrm>
-            <a:off x="6492240" y="2011680"/>
-            <a:ext cx="4937760" cy="2468880"/>
-          </a:xfrm>
-          <a:prstGeom prst="rect">
-            <a:avLst/>
-          </a:prstGeom>
-          <a:noFill/>
-        </p:spPr>
-        <p:txBody>
-          <a:bodyPr wrap="square">
-            <a:spAutoFit/>
-          </a:bodyPr>
-          <a:lstStyle/>
-          <a:p>
-            <a:pPr>
-              <a:lnSpc>
-                <a:spcPct val="110000"/>
-              </a:lnSpc>
-              <a:spcAft>
-                <a:spcPts val="600"/>
-              </a:spcAft>
-            </a:pPr>
-            <a:r>
-              <a:rPr sz="1300">
-                <a:solidFill>
-                  <a:srgbClr val="854D0E"/>
-                </a:solidFill>
-                <a:latin typeface="Calibri"/>
-              </a:rPr>
-              <a:t>—  The RCN Map and RCN Timeline plugins run on the local wiki. On Wiki Café they need an npm publish and an image rebuild first; until then, build pages with --map native.</a:t>
-            </a:r>
-          </a:p>
-          <a:p>
-            <a:pPr>
-              <a:lnSpc>
-                <a:spcPct val="110000"/>
-              </a:lnSpc>
-              <a:spcAft>
-                <a:spcPts val="600"/>
-              </a:spcAft>
-            </a:pPr>
-            <a:r>
-              <a:rPr sz="1300">
-                <a:solidFill>
-                  <a:srgbClr val="854D0E"/>
-                </a:solidFill>
-                <a:latin typeface="Calibri"/>
-              </a:rPr>
-              <a:t>—  Edits in the full Timeline tool do not save back to the page yet.</a:t>
-            </a:r>
-          </a:p>
-          <a:p>
-            <a:pPr>
-              <a:lnSpc>
-                <a:spcPct val="110000"/>
-              </a:lnSpc>
-              <a:spcAft>
-                <a:spcPts val="600"/>
-              </a:spcAft>
-            </a:pPr>
-            <a:r>
-              <a:rPr sz="1300">
-                <a:solidFill>
-                  <a:srgbClr val="854D0E"/>
-                </a:solidFill>
-                <a:latin typeface="Calibri"/>
-              </a:rPr>
-              <a:t>—  Half the co-op websites cannot be shown in a page — ICU, REI, North Coast CU, A1DesignBuild and the Food Hub refuse; Bellingham Bay Builders’ bot check never finishes. Those pages link out.</a:t>
-            </a:r>
-          </a:p>
-        </p:txBody>
-      </p:sp>
-      <p:sp>
-        <p:nvSpPr>
-          <p:cNvPr id="11" name="TextBox 10"/>
-          <p:cNvSpPr txBox="1"/>
-          <p:nvPr/>
-        </p:nvSpPr>
-        <p:spPr>
-          <a:xfrm>
-            <a:off x="548640" y="5212080"/>
-            <a:ext cx="11064240" cy="731520"/>
-          </a:xfrm>
-          <a:prstGeom prst="rect">
-            <a:avLst/>
-          </a:prstGeom>
-          <a:noFill/>
-        </p:spPr>
-        <p:txBody>
-          <a:bodyPr wrap="square" anchor="t">
-            <a:spAutoFit/>
-          </a:bodyPr>
-          <a:lstStyle/>
-          <a:p>
-            <a:pPr algn="l">
-              <a:lnSpc>
-                <a:spcPct val="105000"/>
-              </a:lnSpc>
-            </a:pPr>
-            <a:r>
-              <a:rPr sz="1500" b="0" i="1">
-                <a:solidFill>
-                  <a:srgbClr val="475569"/>
-                </a:solidFill>
-                <a:latin typeface="Calibri"/>
-              </a:rPr>
-              <a:t>Checked in a real FedWiki (coops.localhost) with real clicks: a graph box, a map point and a timeline bar each open their page beside; Open in RCN Timeline loads the page’s timeline; the websites were tested in the frame plugin’s own sandbox or by their headers — 11 show.</a:t>
+              <a:rPr sz="1000" b="0" i="1">
+                <a:solidFill>
+                  <a:srgbClr val="94A3B8"/>
+                </a:solidFill>
+                <a:latin typeface="Calibri"/>
+              </a:rPr>
+              <a:t>What Open Table shows</a:t>
             </a:r>
           </a:p>
         </p:txBody>
@@ -7681,7 +7539,7 @@
             <a:avLst/>
           </a:prstGeom>
           <a:solidFill>
-            <a:srgbClr val="D4A017"/>
+            <a:srgbClr val="B45309"/>
           </a:solidFill>
           <a:ln>
             <a:noFill/>
@@ -7740,11 +7598,11 @@
             <a:r>
               <a:rPr sz="1200" b="1" i="0">
                 <a:solidFill>
-                  <a:srgbClr val="D4A017"/>
-                </a:solidFill>
-                <a:latin typeface="Calibri"/>
-              </a:rPr>
-              <a:t>CONTACTS</a:t>
+                  <a:srgbClr val="B45309"/>
+                </a:solidFill>
+                <a:latin typeface="Calibri"/>
+              </a:rPr>
+              <a:t>FEDWIKI — HOW IT WENT</a:t>
             </a:r>
           </a:p>
         </p:txBody>
@@ -7783,7 +7641,7 @@
                 </a:solidFill>
                 <a:latin typeface="Calibri"/>
               </a:rPr>
-              <a:t>What the contact check found — and what to verify before calling</a:t>
+              <a:t>Making it work: what broke, and what it cannot do</a:t>
             </a:r>
           </a:p>
         </p:txBody>
@@ -7797,7 +7655,7 @@
         <p:spPr>
           <a:xfrm>
             <a:off x="548640" y="1554480"/>
-            <a:ext cx="5486400" cy="3108960"/>
+            <a:ext cx="5486400" cy="3429000"/>
           </a:xfrm>
           <a:prstGeom prst="rect">
             <a:avLst/>
@@ -7868,7 +7726,7 @@
                 </a:solidFill>
                 <a:latin typeface="Calibri"/>
               </a:rPr>
-              <a:t>CORRECTED IN THE DATA</a:t>
+              <a:t>FIXED</a:t>
             </a:r>
           </a:p>
         </p:txBody>
@@ -7882,7 +7740,7 @@
         <p:spPr>
           <a:xfrm>
             <a:off x="777240" y="2011680"/>
-            <a:ext cx="5029200" cy="2560320"/>
+            <a:ext cx="5029200" cy="2468880"/>
           </a:xfrm>
           <a:prstGeom prst="rect">
             <a:avLst/>
@@ -7910,7 +7768,7 @@
                 </a:solidFill>
                 <a:latin typeface="Calibri"/>
               </a:rPr>
-              <a:t>—  Community to Community has moved: 1319 Cornwall Ave, Suite 101 (the map pin is moved).</a:t>
+              <a:t>—  Clicking a two-line name in a graph did nothing, or reloaded the wiki. Each co-op box is now one link. The real fix belongs in the Graph Tool, for every diagram.</a:t>
             </a:r>
           </a:p>
           <a:p>
@@ -7929,7 +7787,7 @@
                 </a:solidFill>
                 <a:latin typeface="Calibri"/>
               </a:rPr>
-              <a:t>—  Cascade Cooperatives incorporated in January 2022, not 2019; it began in 2014 as the Co-op Education Project.</a:t>
+              <a:t>—  Maps first ran inside Frame items, which tied pages to one wiki. Two plugins of our own replaced them — RCN Map and RCN Timeline — and Frame is kept for websites only.</a:t>
             </a:r>
           </a:p>
           <a:p>
@@ -7948,7 +7806,7 @@
                 </a:solidFill>
                 <a:latin typeface="Calibri"/>
               </a:rPr>
-              <a:t>—  CHS Northwest in Lynden is at 402 Main St.</a:t>
+              <a:t>—  Timeline labels ran over each other in a narrow column. They now stop where the next begins, in the page and in the full tool.</a:t>
             </a:r>
           </a:p>
           <a:p>
@@ -7967,26 +7825,7 @@
                 </a:solidFill>
                 <a:latin typeface="Calibri"/>
               </a:rPr>
-              <a:t>—  Industrial Credit Union’s website is industrialcu.com.</a:t>
-            </a:r>
-          </a:p>
-          <a:p>
-            <a:pPr>
-              <a:lnSpc>
-                <a:spcPct val="110000"/>
-              </a:lnSpc>
-              <a:spcAft>
-                <a:spcPts val="600"/>
-              </a:spcAft>
-            </a:pPr>
-            <a:r>
-              <a:rPr sz="1300">
-                <a:solidFill>
-                  <a:srgbClr val="475569"/>
-                </a:solidFill>
-                <a:latin typeface="Calibri"/>
-              </a:rPr>
-              <a:t>—  Yellow Cab Co-op has its own site, yellowcabcoop.com.</a:t>
+              <a:t>—  The Timeline tool dropped fields it did not know, so a co-op link vanished on save; and a second “Open” left it on the first timeline. Both fixed.</a:t>
             </a:r>
           </a:p>
         </p:txBody>
@@ -8000,7 +7839,7 @@
         <p:spPr>
           <a:xfrm>
             <a:off x="6263640" y="1554480"/>
-            <a:ext cx="5394960" cy="3108960"/>
+            <a:ext cx="5394960" cy="3429000"/>
           </a:xfrm>
           <a:prstGeom prst="rect">
             <a:avLst/>
@@ -8071,7 +7910,7 @@
                 </a:solidFill>
                 <a:latin typeface="Calibri"/>
               </a:rPr>
-              <a:t>VERIFY BEFORE RELYING ON IT</a:t>
+              <a:t>LIMITS</a:t>
             </a:r>
           </a:p>
         </p:txBody>
@@ -8085,7 +7924,7 @@
         <p:spPr>
           <a:xfrm>
             <a:off x="6492240" y="2011680"/>
-            <a:ext cx="4937760" cy="2560320"/>
+            <a:ext cx="4937760" cy="2468880"/>
           </a:xfrm>
           <a:prstGeom prst="rect">
             <a:avLst/>
@@ -8113,7 +7952,7 @@
                 </a:solidFill>
                 <a:latin typeface="Calibri"/>
               </a:rPr>
-              <a:t>—  Community Media Cooperative — media-coop.com no longer resolves; it may have closed.</a:t>
+              <a:t>—  The RCN Map and RCN Timeline plugins run on the local wiki. On Wiki Café they need an npm publish and an image rebuild first; until then, build pages with --map native.</a:t>
             </a:r>
           </a:p>
           <a:p>
@@ -8132,7 +7971,7 @@
                 </a:solidFill>
                 <a:latin typeface="Calibri"/>
               </a:rPr>
-              <a:t>—  Cascadia Deaf Nation — website answers “Payment Required”; it may have lapsed.</a:t>
+              <a:t>—  Edits in the full Timeline tool do not save back to the page yet.</a:t>
             </a:r>
           </a:p>
           <a:p>
@@ -8151,45 +7990,7 @@
                 </a:solidFill>
                 <a:latin typeface="Calibri"/>
               </a:rPr>
-              <a:t>—  Bellingham Bay Builders — only the 2004 founders are published, not the current owner-members.</a:t>
-            </a:r>
-          </a:p>
-          <a:p>
-            <a:pPr>
-              <a:lnSpc>
-                <a:spcPct val="110000"/>
-              </a:lnSpc>
-              <a:spcAft>
-                <a:spcPts val="600"/>
-              </a:spcAft>
-            </a:pPr>
-            <a:r>
-              <a:rPr sz="1300">
-                <a:solidFill>
-                  <a:srgbClr val="854D0E"/>
-                </a:solidFill>
-                <a:latin typeface="Calibri"/>
-              </a:rPr>
-              <a:t>—  WestEdge CU, Yellow Cab Co-op, Circle of Life, CHS — no leader named on their own sites.</a:t>
-            </a:r>
-          </a:p>
-          <a:p>
-            <a:pPr>
-              <a:lnSpc>
-                <a:spcPct val="110000"/>
-              </a:lnSpc>
-              <a:spcAft>
-                <a:spcPts val="600"/>
-              </a:spcAft>
-            </a:pPr>
-            <a:r>
-              <a:rPr sz="1300">
-                <a:solidFill>
-                  <a:srgbClr val="854D0E"/>
-                </a:solidFill>
-                <a:latin typeface="Calibri"/>
-              </a:rPr>
-              <a:t>—  Tierra y Libertad — no website of its own; reach it through C2C.</a:t>
+              <a:t>—  Half the co-op websites cannot be shown in a page — ICU, REI, North Coast CU, A1DesignBuild and the Food Hub refuse; Bellingham Bay Builders’ bot check never finishes. Those pages link out.</a:t>
             </a:r>
           </a:p>
         </p:txBody>
@@ -8202,7 +8003,7 @@
         </p:nvSpPr>
         <p:spPr>
           <a:xfrm>
-            <a:off x="548640" y="4983480"/>
+            <a:off x="548640" y="5212080"/>
             <a:ext cx="11064240" cy="731520"/>
           </a:xfrm>
           <a:prstGeom prst="rect">
@@ -8228,7 +8029,7 @@
                 </a:solidFill>
                 <a:latin typeface="Calibri"/>
               </a:rPr>
-              <a:t>Every contact carries “Checked Sep 2026” and the page it was read from. Phones and names change; the date says how far to trust them.</a:t>
+              <a:t>Checked in a real FedWiki (coops.localhost) with real clicks: a graph box, a map point and a timeline bar each open their page beside; Open in RCN Timeline loads the page’s timeline; the websites were tested in the frame plugin’s own sandbox or by their headers — 11 show.</a:t>
             </a:r>
           </a:p>
         </p:txBody>
@@ -8325,7 +8126,7 @@
     <p:bg>
       <p:bgPr>
         <a:solidFill>
-          <a:srgbClr val="1E293B"/>
+          <a:srgbClr val="F8FAFC"/>
         </a:solidFill>
         <a:effectLst/>
       </p:bgPr>
@@ -8339,14 +8140,58 @@
       <p:grpSpPr/>
       <p:sp>
         <p:nvSpPr>
-          <p:cNvPr id="2" name="TextBox 1"/>
-          <p:cNvSpPr txBox="1"/>
-          <p:nvPr/>
-        </p:nvSpPr>
-        <p:spPr>
-          <a:xfrm>
-            <a:off x="640080" y="822960"/>
-            <a:ext cx="10972800" cy="731520"/>
+          <p:cNvPr id="2" name="Rectangle 1"/>
+          <p:cNvSpPr/>
+          <p:nvPr/>
+        </p:nvSpPr>
+        <p:spPr>
+          <a:xfrm>
+            <a:off x="548640" y="384048"/>
+            <a:ext cx="82296" cy="274320"/>
+          </a:xfrm>
+          <a:prstGeom prst="rect">
+            <a:avLst/>
+          </a:prstGeom>
+          <a:solidFill>
+            <a:srgbClr val="D4A017"/>
+          </a:solidFill>
+          <a:ln>
+            <a:noFill/>
+          </a:ln>
+          <a:effectLst/>
+        </p:spPr>
+        <p:style>
+          <a:lnRef idx="1">
+            <a:schemeClr val="accent1"/>
+          </a:lnRef>
+          <a:fillRef idx="3">
+            <a:schemeClr val="accent1"/>
+          </a:fillRef>
+          <a:effectRef idx="2">
+            <a:schemeClr val="accent1"/>
+          </a:effectRef>
+          <a:fontRef idx="minor">
+            <a:schemeClr val="lt1"/>
+          </a:fontRef>
+        </p:style>
+        <p:txBody>
+          <a:bodyPr rtlCol="0" anchor="ctr"/>
+          <a:lstStyle/>
+          <a:p>
+            <a:pPr algn="ctr"/>
+          </a:p>
+        </p:txBody>
+      </p:sp>
+      <p:sp>
+        <p:nvSpPr>
+          <p:cNvPr id="3" name="TextBox 2"/>
+          <p:cNvSpPr txBox="1"/>
+          <p:nvPr/>
+        </p:nvSpPr>
+        <p:spPr>
+          <a:xfrm>
+            <a:off x="731520" y="365760"/>
+            <a:ext cx="7315200" cy="320040"/>
           </a:xfrm>
           <a:prstGeom prst="rect">
             <a:avLst/>
@@ -8365,27 +8210,151 @@
               </a:lnSpc>
             </a:pPr>
             <a:r>
-              <a:rPr sz="3600" b="1" i="0">
-                <a:solidFill>
-                  <a:srgbClr val="FFFFFF"/>
-                </a:solidFill>
-                <a:latin typeface="Calibri"/>
-              </a:rPr>
-              <a:t>One dataset, four lenses</a:t>
-            </a:r>
-          </a:p>
-        </p:txBody>
-      </p:sp>
-      <p:sp>
-        <p:nvSpPr>
-          <p:cNvPr id="3" name="TextBox 2"/>
-          <p:cNvSpPr txBox="1"/>
-          <p:nvPr/>
-        </p:nvSpPr>
-        <p:spPr>
-          <a:xfrm>
-            <a:off x="640080" y="1737360"/>
-            <a:ext cx="10789920" cy="3291840"/>
+              <a:rPr sz="1200" b="1" i="0">
+                <a:solidFill>
+                  <a:srgbClr val="D4A017"/>
+                </a:solidFill>
+                <a:latin typeface="Calibri"/>
+              </a:rPr>
+              <a:t>CONTACTS</a:t>
+            </a:r>
+          </a:p>
+        </p:txBody>
+      </p:sp>
+      <p:sp>
+        <p:nvSpPr>
+          <p:cNvPr id="4" name="TextBox 3"/>
+          <p:cNvSpPr txBox="1"/>
+          <p:nvPr/>
+        </p:nvSpPr>
+        <p:spPr>
+          <a:xfrm>
+            <a:off x="548640" y="713232"/>
+            <a:ext cx="11155680" cy="640080"/>
+          </a:xfrm>
+          <a:prstGeom prst="rect">
+            <a:avLst/>
+          </a:prstGeom>
+          <a:noFill/>
+        </p:spPr>
+        <p:txBody>
+          <a:bodyPr wrap="square" anchor="t">
+            <a:spAutoFit/>
+          </a:bodyPr>
+          <a:lstStyle/>
+          <a:p>
+            <a:pPr algn="l">
+              <a:lnSpc>
+                <a:spcPct val="105000"/>
+              </a:lnSpc>
+            </a:pPr>
+            <a:r>
+              <a:rPr sz="2800" b="1" i="0">
+                <a:solidFill>
+                  <a:srgbClr val="0F172A"/>
+                </a:solidFill>
+                <a:latin typeface="Calibri"/>
+              </a:rPr>
+              <a:t>What the contact check found — and what to verify before calling</a:t>
+            </a:r>
+          </a:p>
+        </p:txBody>
+      </p:sp>
+      <p:sp>
+        <p:nvSpPr>
+          <p:cNvPr id="5" name="Rectangle 4"/>
+          <p:cNvSpPr/>
+          <p:nvPr/>
+        </p:nvSpPr>
+        <p:spPr>
+          <a:xfrm>
+            <a:off x="548640" y="1554480"/>
+            <a:ext cx="5486400" cy="3108960"/>
+          </a:xfrm>
+          <a:prstGeom prst="rect">
+            <a:avLst/>
+          </a:prstGeom>
+          <a:solidFill>
+            <a:srgbClr val="FFFFFF"/>
+          </a:solidFill>
+          <a:ln w="12700">
+            <a:solidFill>
+              <a:srgbClr val="E2E8F0"/>
+            </a:solidFill>
+          </a:ln>
+          <a:effectLst/>
+        </p:spPr>
+        <p:style>
+          <a:lnRef idx="1">
+            <a:schemeClr val="accent1"/>
+          </a:lnRef>
+          <a:fillRef idx="3">
+            <a:schemeClr val="accent1"/>
+          </a:fillRef>
+          <a:effectRef idx="2">
+            <a:schemeClr val="accent1"/>
+          </a:effectRef>
+          <a:fontRef idx="minor">
+            <a:schemeClr val="lt1"/>
+          </a:fontRef>
+        </p:style>
+        <p:txBody>
+          <a:bodyPr rtlCol="0" anchor="ctr"/>
+          <a:lstStyle/>
+          <a:p>
+            <a:pPr algn="ctr"/>
+          </a:p>
+        </p:txBody>
+      </p:sp>
+      <p:sp>
+        <p:nvSpPr>
+          <p:cNvPr id="6" name="TextBox 5"/>
+          <p:cNvSpPr txBox="1"/>
+          <p:nvPr/>
+        </p:nvSpPr>
+        <p:spPr>
+          <a:xfrm>
+            <a:off x="777240" y="1691640"/>
+            <a:ext cx="5029200" cy="274320"/>
+          </a:xfrm>
+          <a:prstGeom prst="rect">
+            <a:avLst/>
+          </a:prstGeom>
+          <a:noFill/>
+        </p:spPr>
+        <p:txBody>
+          <a:bodyPr wrap="square" anchor="t">
+            <a:spAutoFit/>
+          </a:bodyPr>
+          <a:lstStyle/>
+          <a:p>
+            <a:pPr algn="l">
+              <a:lnSpc>
+                <a:spcPct val="105000"/>
+              </a:lnSpc>
+            </a:pPr>
+            <a:r>
+              <a:rPr sz="1100" b="1" i="0">
+                <a:solidFill>
+                  <a:srgbClr val="1A7A4A"/>
+                </a:solidFill>
+                <a:latin typeface="Calibri"/>
+              </a:rPr>
+              <a:t>CORRECTED IN THE DATA</a:t>
+            </a:r>
+          </a:p>
+        </p:txBody>
+      </p:sp>
+      <p:sp>
+        <p:nvSpPr>
+          <p:cNvPr id="7" name="TextBox 6"/>
+          <p:cNvSpPr txBox="1"/>
+          <p:nvPr/>
+        </p:nvSpPr>
+        <p:spPr>
+          <a:xfrm>
+            <a:off x="777240" y="2011680"/>
+            <a:ext cx="5029200" cy="2560320"/>
           </a:xfrm>
           <a:prstGeom prst="rect">
             <a:avLst/>
@@ -8403,17 +8372,17 @@
                 <a:spcPct val="110000"/>
               </a:lnSpc>
               <a:spcAft>
-                <a:spcPts val="800"/>
+                <a:spcPts val="600"/>
               </a:spcAft>
             </a:pPr>
             <a:r>
-              <a:rPr sz="1600">
-                <a:solidFill>
-                  <a:srgbClr val="CBD5E1"/>
-                </a:solidFill>
-                <a:latin typeface="Calibri"/>
-              </a:rPr>
-              <a:t>—  Map: open the RCN Map and choose the “Co-ops of Whatcom County” issue — hover any dot for its contact.</a:t>
+              <a:rPr sz="1300">
+                <a:solidFill>
+                  <a:srgbClr val="475569"/>
+                </a:solidFill>
+                <a:latin typeface="Calibri"/>
+              </a:rPr>
+              <a:t>—  Community to Community has moved: 1319 Cornwall Ave, Suite 101 (the map pin is moved).</a:t>
             </a:r>
           </a:p>
           <a:p>
@@ -8422,17 +8391,17 @@
                 <a:spcPct val="110000"/>
               </a:lnSpc>
               <a:spcAft>
-                <a:spcPts val="800"/>
+                <a:spcPts val="600"/>
               </a:spcAft>
             </a:pPr>
             <a:r>
-              <a:rPr sz="1600">
-                <a:solidFill>
-                  <a:srgbClr val="CBD5E1"/>
-                </a:solidFill>
-                <a:latin typeface="Calibri"/>
-              </a:rPr>
-              <a:t>—  Graph: “Open in Graph Tool” from the map legend, or load tools/whatcom-coops-graph.json (Marc’s layout, with contacts).</a:t>
+              <a:rPr sz="1300">
+                <a:solidFill>
+                  <a:srgbClr val="475569"/>
+                </a:solidFill>
+                <a:latin typeface="Calibri"/>
+              </a:rPr>
+              <a:t>—  Cascade Cooperatives incorporated in January 2022, not 2019; it began in 2014 as the Co-op Education Project.</a:t>
             </a:r>
           </a:p>
           <a:p>
@@ -8441,17 +8410,17 @@
                 <a:spcPct val="110000"/>
               </a:lnSpc>
               <a:spcAft>
-                <a:spcPts val="800"/>
+                <a:spcPts val="600"/>
               </a:spcAft>
             </a:pPr>
             <a:r>
-              <a:rPr sz="1600">
-                <a:solidFill>
-                  <a:srgbClr val="CBD5E1"/>
-                </a:solidFill>
-                <a:latin typeface="Calibri"/>
-              </a:rPr>
-              <a:t>—  Timeline: import tools/whatcom-coops-timeline.json into the RCN Timeline.</a:t>
+              <a:rPr sz="1300">
+                <a:solidFill>
+                  <a:srgbClr val="475569"/>
+                </a:solidFill>
+                <a:latin typeface="Calibri"/>
+              </a:rPr>
+              <a:t>—  CHS Northwest in Lynden is at 402 Main St.</a:t>
             </a:r>
           </a:p>
           <a:p>
@@ -8460,17 +8429,17 @@
                 <a:spcPct val="110000"/>
               </a:lnSpc>
               <a:spcAft>
-                <a:spcPts val="800"/>
+                <a:spcPts val="600"/>
               </a:spcAft>
             </a:pPr>
             <a:r>
-              <a:rPr sz="1600">
-                <a:solidFill>
-                  <a:srgbClr val="CBD5E1"/>
-                </a:solidFill>
-                <a:latin typeface="Calibri"/>
-              </a:rPr>
-              <a:t>—  Table: rcn-table.html?db=whatcomcoops&amp;kind=Coop, with substrate/api.py running.</a:t>
+              <a:rPr sz="1300">
+                <a:solidFill>
+                  <a:srgbClr val="475569"/>
+                </a:solidFill>
+                <a:latin typeface="Calibri"/>
+              </a:rPr>
+              <a:t>—  Industrial Credit Union’s website is industrialcu.com.</a:t>
             </a:r>
           </a:p>
           <a:p>
@@ -8479,50 +8448,234 @@
                 <a:spcPct val="110000"/>
               </a:lnSpc>
               <a:spcAft>
-                <a:spcPts val="800"/>
+                <a:spcPts val="600"/>
               </a:spcAft>
             </a:pPr>
             <a:r>
-              <a:rPr sz="1600">
-                <a:solidFill>
-                  <a:srgbClr val="CBD5E1"/>
-                </a:solidFill>
-                <a:latin typeface="Calibri"/>
-              </a:rPr>
-              <a:t>—  FedWiki: drag docs/whatcom-coops-wiki/whatcom-coops-wiki.json onto a lineup on a wiki with the RCN Map and RCN Timeline plugins; “Open in RCN Timeline” opens any page’s timeline in the full tool.</a:t>
-            </a:r>
-          </a:p>
+              <a:rPr sz="1300">
+                <a:solidFill>
+                  <a:srgbClr val="475569"/>
+                </a:solidFill>
+                <a:latin typeface="Calibri"/>
+              </a:rPr>
+              <a:t>—  Yellow Cab Co-op has its own site, yellowcabcoop.com.</a:t>
+            </a:r>
+          </a:p>
+        </p:txBody>
+      </p:sp>
+      <p:sp>
+        <p:nvSpPr>
+          <p:cNvPr id="8" name="Rectangle 7"/>
+          <p:cNvSpPr/>
+          <p:nvPr/>
+        </p:nvSpPr>
+        <p:spPr>
+          <a:xfrm>
+            <a:off x="6263640" y="1554480"/>
+            <a:ext cx="5394960" cy="3108960"/>
+          </a:xfrm>
+          <a:prstGeom prst="rect">
+            <a:avLst/>
+          </a:prstGeom>
+          <a:solidFill>
+            <a:srgbClr val="FEF3C7"/>
+          </a:solidFill>
+          <a:ln w="12700">
+            <a:solidFill>
+              <a:srgbClr val="FDE047"/>
+            </a:solidFill>
+          </a:ln>
+          <a:effectLst/>
+        </p:spPr>
+        <p:style>
+          <a:lnRef idx="1">
+            <a:schemeClr val="accent1"/>
+          </a:lnRef>
+          <a:fillRef idx="3">
+            <a:schemeClr val="accent1"/>
+          </a:fillRef>
+          <a:effectRef idx="2">
+            <a:schemeClr val="accent1"/>
+          </a:effectRef>
+          <a:fontRef idx="minor">
+            <a:schemeClr val="lt1"/>
+          </a:fontRef>
+        </p:style>
+        <p:txBody>
+          <a:bodyPr rtlCol="0" anchor="ctr"/>
+          <a:lstStyle/>
+          <a:p>
+            <a:pPr algn="ctr"/>
+          </a:p>
+        </p:txBody>
+      </p:sp>
+      <p:sp>
+        <p:nvSpPr>
+          <p:cNvPr id="9" name="TextBox 8"/>
+          <p:cNvSpPr txBox="1"/>
+          <p:nvPr/>
+        </p:nvSpPr>
+        <p:spPr>
+          <a:xfrm>
+            <a:off x="6492240" y="1691640"/>
+            <a:ext cx="4937760" cy="274320"/>
+          </a:xfrm>
+          <a:prstGeom prst="rect">
+            <a:avLst/>
+          </a:prstGeom>
+          <a:noFill/>
+        </p:spPr>
+        <p:txBody>
+          <a:bodyPr wrap="square" anchor="t">
+            <a:spAutoFit/>
+          </a:bodyPr>
+          <a:lstStyle/>
+          <a:p>
+            <a:pPr algn="l">
+              <a:lnSpc>
+                <a:spcPct val="105000"/>
+              </a:lnSpc>
+            </a:pPr>
+            <a:r>
+              <a:rPr sz="1100" b="1" i="0">
+                <a:solidFill>
+                  <a:srgbClr val="854D0E"/>
+                </a:solidFill>
+                <a:latin typeface="Calibri"/>
+              </a:rPr>
+              <a:t>VERIFY BEFORE RELYING ON IT</a:t>
+            </a:r>
+          </a:p>
+        </p:txBody>
+      </p:sp>
+      <p:sp>
+        <p:nvSpPr>
+          <p:cNvPr id="10" name="TextBox 9"/>
+          <p:cNvSpPr txBox="1"/>
+          <p:nvPr/>
+        </p:nvSpPr>
+        <p:spPr>
+          <a:xfrm>
+            <a:off x="6492240" y="2011680"/>
+            <a:ext cx="4937760" cy="2560320"/>
+          </a:xfrm>
+          <a:prstGeom prst="rect">
+            <a:avLst/>
+          </a:prstGeom>
+          <a:noFill/>
+        </p:spPr>
+        <p:txBody>
+          <a:bodyPr wrap="square">
+            <a:spAutoFit/>
+          </a:bodyPr>
+          <a:lstStyle/>
           <a:p>
             <a:pPr>
               <a:lnSpc>
                 <a:spcPct val="110000"/>
               </a:lnSpc>
               <a:spcAft>
-                <a:spcPts val="800"/>
+                <a:spcPts val="600"/>
               </a:spcAft>
             </a:pPr>
             <a:r>
-              <a:rPr sz="1600">
-                <a:solidFill>
-                  <a:srgbClr val="CBD5E1"/>
-                </a:solidFill>
-                <a:latin typeface="Calibri"/>
-              </a:rPr>
-              <a:t>—  To change the data, edit the issue file, then re-run substrate/load_coops.py and build_pages.py so Neo4j and the wiki match.</a:t>
-            </a:r>
-          </a:p>
-        </p:txBody>
-      </p:sp>
-      <p:sp>
-        <p:nvSpPr>
-          <p:cNvPr id="4" name="TextBox 3"/>
-          <p:cNvSpPr txBox="1"/>
-          <p:nvPr/>
-        </p:nvSpPr>
-        <p:spPr>
-          <a:xfrm>
-            <a:off x="640080" y="5029200"/>
-            <a:ext cx="10789920" cy="457200"/>
+              <a:rPr sz="1300">
+                <a:solidFill>
+                  <a:srgbClr val="854D0E"/>
+                </a:solidFill>
+                <a:latin typeface="Calibri"/>
+              </a:rPr>
+              <a:t>—  Community Media Cooperative — media-coop.com no longer resolves; it may have closed.</a:t>
+            </a:r>
+          </a:p>
+          <a:p>
+            <a:pPr>
+              <a:lnSpc>
+                <a:spcPct val="110000"/>
+              </a:lnSpc>
+              <a:spcAft>
+                <a:spcPts val="600"/>
+              </a:spcAft>
+            </a:pPr>
+            <a:r>
+              <a:rPr sz="1300">
+                <a:solidFill>
+                  <a:srgbClr val="854D0E"/>
+                </a:solidFill>
+                <a:latin typeface="Calibri"/>
+              </a:rPr>
+              <a:t>—  Cascadia Deaf Nation — website answers “Payment Required”; it may have lapsed.</a:t>
+            </a:r>
+          </a:p>
+          <a:p>
+            <a:pPr>
+              <a:lnSpc>
+                <a:spcPct val="110000"/>
+              </a:lnSpc>
+              <a:spcAft>
+                <a:spcPts val="600"/>
+              </a:spcAft>
+            </a:pPr>
+            <a:r>
+              <a:rPr sz="1300">
+                <a:solidFill>
+                  <a:srgbClr val="854D0E"/>
+                </a:solidFill>
+                <a:latin typeface="Calibri"/>
+              </a:rPr>
+              <a:t>—  Bellingham Bay Builders — only the 2004 founders are published, not the current owner-members.</a:t>
+            </a:r>
+          </a:p>
+          <a:p>
+            <a:pPr>
+              <a:lnSpc>
+                <a:spcPct val="110000"/>
+              </a:lnSpc>
+              <a:spcAft>
+                <a:spcPts val="600"/>
+              </a:spcAft>
+            </a:pPr>
+            <a:r>
+              <a:rPr sz="1300">
+                <a:solidFill>
+                  <a:srgbClr val="854D0E"/>
+                </a:solidFill>
+                <a:latin typeface="Calibri"/>
+              </a:rPr>
+              <a:t>—  WestEdge CU, Yellow Cab Co-op, Circle of Life, CHS — no leader named on their own sites.</a:t>
+            </a:r>
+          </a:p>
+          <a:p>
+            <a:pPr>
+              <a:lnSpc>
+                <a:spcPct val="110000"/>
+              </a:lnSpc>
+              <a:spcAft>
+                <a:spcPts val="600"/>
+              </a:spcAft>
+            </a:pPr>
+            <a:r>
+              <a:rPr sz="1300">
+                <a:solidFill>
+                  <a:srgbClr val="854D0E"/>
+                </a:solidFill>
+                <a:latin typeface="Calibri"/>
+              </a:rPr>
+              <a:t>—  Tierra y Libertad — no website of its own; reach it through C2C.</a:t>
+            </a:r>
+          </a:p>
+        </p:txBody>
+      </p:sp>
+      <p:sp>
+        <p:nvSpPr>
+          <p:cNvPr id="11" name="TextBox 10"/>
+          <p:cNvSpPr txBox="1"/>
+          <p:nvPr/>
+        </p:nvSpPr>
+        <p:spPr>
+          <a:xfrm>
+            <a:off x="548640" y="4983480"/>
+            <a:ext cx="11064240" cy="731520"/>
           </a:xfrm>
           <a:prstGeom prst="rect">
             <a:avLst/>
@@ -8541,27 +8694,66 @@
               </a:lnSpc>
             </a:pPr>
             <a:r>
-              <a:rPr sz="1400" b="0" i="1">
+              <a:rPr sz="1500" b="0" i="1">
+                <a:solidFill>
+                  <a:srgbClr val="475569"/>
+                </a:solidFill>
+                <a:latin typeface="Calibri"/>
+              </a:rPr>
+              <a:t>Every contact carries “Checked Sep 2026” and the page it was read from. Phones and names change; the date says how far to trust them.</a:t>
+            </a:r>
+          </a:p>
+        </p:txBody>
+      </p:sp>
+      <p:sp>
+        <p:nvSpPr>
+          <p:cNvPr id="12" name="TextBox 11"/>
+          <p:cNvSpPr txBox="1"/>
+          <p:nvPr/>
+        </p:nvSpPr>
+        <p:spPr>
+          <a:xfrm>
+            <a:off x="548640" y="6446520"/>
+            <a:ext cx="5486400" cy="274320"/>
+          </a:xfrm>
+          <a:prstGeom prst="rect">
+            <a:avLst/>
+          </a:prstGeom>
+          <a:noFill/>
+        </p:spPr>
+        <p:txBody>
+          <a:bodyPr wrap="square" anchor="t">
+            <a:spAutoFit/>
+          </a:bodyPr>
+          <a:lstStyle/>
+          <a:p>
+            <a:pPr algn="l">
+              <a:lnSpc>
+                <a:spcPct val="105000"/>
+              </a:lnSpc>
+            </a:pPr>
+            <a:r>
+              <a:rPr sz="900" b="0" i="0">
                 <a:solidFill>
                   <a:srgbClr val="94A3B8"/>
                 </a:solidFill>
                 <a:latin typeface="Calibri"/>
               </a:rPr>
-              <a:t>A line means a public source was found. No line means no tie was found, not that none exists.</a:t>
-            </a:r>
-          </a:p>
-        </p:txBody>
-      </p:sp>
-      <p:sp>
-        <p:nvSpPr>
-          <p:cNvPr id="5" name="TextBox 4"/>
-          <p:cNvSpPr txBox="1"/>
-          <p:nvPr/>
-        </p:nvSpPr>
-        <p:spPr>
-          <a:xfrm>
-            <a:off x="640080" y="6035040"/>
-            <a:ext cx="10058400" cy="365760"/>
+              <a:t>Co-ops of Whatcom County · RCN</a:t>
+            </a:r>
+          </a:p>
+        </p:txBody>
+      </p:sp>
+      <p:sp>
+        <p:nvSpPr>
+          <p:cNvPr id="13" name="TextBox 12"/>
+          <p:cNvSpPr txBox="1"/>
+          <p:nvPr/>
+        </p:nvSpPr>
+        <p:spPr>
+          <a:xfrm>
+            <a:off x="11247120" y="6446520"/>
+            <a:ext cx="365760" cy="274320"/>
           </a:xfrm>
           <a:prstGeom prst="rect">
             <a:avLst/>
@@ -8574,19 +8766,19 @@
           </a:bodyPr>
           <a:lstStyle/>
           <a:p>
-            <a:pPr algn="l">
+            <a:pPr algn="r">
               <a:lnSpc>
                 <a:spcPct val="105000"/>
               </a:lnSpc>
             </a:pPr>
             <a:r>
-              <a:rPr sz="1200" b="0" i="0">
-                <a:solidFill>
-                  <a:srgbClr val="CBD5E1"/>
-                </a:solidFill>
-                <a:latin typeface="Calibri"/>
-              </a:rPr>
-              <a:t>Marc Pierson with Claude Opus 5.5 · September 2026</a:t>
+              <a:rPr sz="900" b="0" i="0">
+                <a:solidFill>
+                  <a:srgbClr val="94A3B8"/>
+                </a:solidFill>
+                <a:latin typeface="Calibri"/>
+              </a:rPr>
+              <a:t>19</a:t>
             </a:r>
           </a:p>
         </p:txBody>
@@ -9798,6 +9990,286 @@
                 <a:latin typeface="Calibri"/>
               </a:rPr>
               <a:t>2</a:t>
+            </a:r>
+          </a:p>
+        </p:txBody>
+      </p:sp>
+    </p:spTree>
+  </p:cSld>
+  <p:clrMapOvr>
+    <a:masterClrMapping/>
+  </p:clrMapOvr>
+</p:sld>
+</file>
+
+<file path=ppt/slides/slide20.xml><?xml version="1.0" encoding="utf-8"?>
+<p:sld xmlns:a="http://schemas.openxmlformats.org/drawingml/2006/main" xmlns:p="http://schemas.openxmlformats.org/presentationml/2006/main" xmlns:r="http://schemas.openxmlformats.org/officeDocument/2006/relationships">
+  <p:cSld>
+    <p:bg>
+      <p:bgPr>
+        <a:solidFill>
+          <a:srgbClr val="1E293B"/>
+        </a:solidFill>
+        <a:effectLst/>
+      </p:bgPr>
+    </p:bg>
+    <p:spTree>
+      <p:nvGrpSpPr>
+        <p:cNvPr id="1" name=""/>
+        <p:cNvGrpSpPr/>
+        <p:nvPr/>
+      </p:nvGrpSpPr>
+      <p:grpSpPr/>
+      <p:sp>
+        <p:nvSpPr>
+          <p:cNvPr id="2" name="TextBox 1"/>
+          <p:cNvSpPr txBox="1"/>
+          <p:nvPr/>
+        </p:nvSpPr>
+        <p:spPr>
+          <a:xfrm>
+            <a:off x="640080" y="822960"/>
+            <a:ext cx="10972800" cy="731520"/>
+          </a:xfrm>
+          <a:prstGeom prst="rect">
+            <a:avLst/>
+          </a:prstGeom>
+          <a:noFill/>
+        </p:spPr>
+        <p:txBody>
+          <a:bodyPr wrap="square" anchor="t">
+            <a:spAutoFit/>
+          </a:bodyPr>
+          <a:lstStyle/>
+          <a:p>
+            <a:pPr algn="l">
+              <a:lnSpc>
+                <a:spcPct val="105000"/>
+              </a:lnSpc>
+            </a:pPr>
+            <a:r>
+              <a:rPr sz="3600" b="1" i="0">
+                <a:solidFill>
+                  <a:srgbClr val="FFFFFF"/>
+                </a:solidFill>
+                <a:latin typeface="Calibri"/>
+              </a:rPr>
+              <a:t>One dataset, four lenses</a:t>
+            </a:r>
+          </a:p>
+        </p:txBody>
+      </p:sp>
+      <p:sp>
+        <p:nvSpPr>
+          <p:cNvPr id="3" name="TextBox 2"/>
+          <p:cNvSpPr txBox="1"/>
+          <p:nvPr/>
+        </p:nvSpPr>
+        <p:spPr>
+          <a:xfrm>
+            <a:off x="640080" y="1737360"/>
+            <a:ext cx="10789920" cy="3291840"/>
+          </a:xfrm>
+          <a:prstGeom prst="rect">
+            <a:avLst/>
+          </a:prstGeom>
+          <a:noFill/>
+        </p:spPr>
+        <p:txBody>
+          <a:bodyPr wrap="square">
+            <a:spAutoFit/>
+          </a:bodyPr>
+          <a:lstStyle/>
+          <a:p>
+            <a:pPr>
+              <a:lnSpc>
+                <a:spcPct val="110000"/>
+              </a:lnSpc>
+              <a:spcAft>
+                <a:spcPts val="800"/>
+              </a:spcAft>
+            </a:pPr>
+            <a:r>
+              <a:rPr sz="1600">
+                <a:solidFill>
+                  <a:srgbClr val="CBD5E1"/>
+                </a:solidFill>
+                <a:latin typeface="Calibri"/>
+              </a:rPr>
+              <a:t>—  Map: open the RCN Map and choose the “Co-ops of Whatcom County” issue — hover any dot for its contact.</a:t>
+            </a:r>
+          </a:p>
+          <a:p>
+            <a:pPr>
+              <a:lnSpc>
+                <a:spcPct val="110000"/>
+              </a:lnSpc>
+              <a:spcAft>
+                <a:spcPts val="800"/>
+              </a:spcAft>
+            </a:pPr>
+            <a:r>
+              <a:rPr sz="1600">
+                <a:solidFill>
+                  <a:srgbClr val="CBD5E1"/>
+                </a:solidFill>
+                <a:latin typeface="Calibri"/>
+              </a:rPr>
+              <a:t>—  Graph: “Open in Graph Tool” from the map legend, or load tools/whatcom-coops-graph.json (Marc’s layout, with contacts).</a:t>
+            </a:r>
+          </a:p>
+          <a:p>
+            <a:pPr>
+              <a:lnSpc>
+                <a:spcPct val="110000"/>
+              </a:lnSpc>
+              <a:spcAft>
+                <a:spcPts val="800"/>
+              </a:spcAft>
+            </a:pPr>
+            <a:r>
+              <a:rPr sz="1600">
+                <a:solidFill>
+                  <a:srgbClr val="CBD5E1"/>
+                </a:solidFill>
+                <a:latin typeface="Calibri"/>
+              </a:rPr>
+              <a:t>—  Timeline: import tools/whatcom-coops-timeline.json into the RCN Timeline.</a:t>
+            </a:r>
+          </a:p>
+          <a:p>
+            <a:pPr>
+              <a:lnSpc>
+                <a:spcPct val="110000"/>
+              </a:lnSpc>
+              <a:spcAft>
+                <a:spcPts val="800"/>
+              </a:spcAft>
+            </a:pPr>
+            <a:r>
+              <a:rPr sz="1600">
+                <a:solidFill>
+                  <a:srgbClr val="CBD5E1"/>
+                </a:solidFill>
+                <a:latin typeface="Calibri"/>
+              </a:rPr>
+              <a:t>—  Table: rcn-table.html?db=whatcomcoops&amp;kind=Coop, with substrate/api.py running.</a:t>
+            </a:r>
+          </a:p>
+          <a:p>
+            <a:pPr>
+              <a:lnSpc>
+                <a:spcPct val="110000"/>
+              </a:lnSpc>
+              <a:spcAft>
+                <a:spcPts val="800"/>
+              </a:spcAft>
+            </a:pPr>
+            <a:r>
+              <a:rPr sz="1600">
+                <a:solidFill>
+                  <a:srgbClr val="CBD5E1"/>
+                </a:solidFill>
+                <a:latin typeface="Calibri"/>
+              </a:rPr>
+              <a:t>—  FedWiki: drag docs/whatcom-coops-wiki/whatcom-coops-wiki.json onto a lineup on a wiki with the RCN Map and RCN Timeline plugins; “Open in RCN Timeline” opens any page’s timeline in the full tool.</a:t>
+            </a:r>
+          </a:p>
+          <a:p>
+            <a:pPr>
+              <a:lnSpc>
+                <a:spcPct val="110000"/>
+              </a:lnSpc>
+              <a:spcAft>
+                <a:spcPts val="800"/>
+              </a:spcAft>
+            </a:pPr>
+            <a:r>
+              <a:rPr sz="1600">
+                <a:solidFill>
+                  <a:srgbClr val="CBD5E1"/>
+                </a:solidFill>
+                <a:latin typeface="Calibri"/>
+              </a:rPr>
+              <a:t>—  To change the data, edit the issue file, then re-run substrate/load_coops.py and build_pages.py so Neo4j and the wiki match.</a:t>
+            </a:r>
+          </a:p>
+        </p:txBody>
+      </p:sp>
+      <p:sp>
+        <p:nvSpPr>
+          <p:cNvPr id="4" name="TextBox 3"/>
+          <p:cNvSpPr txBox="1"/>
+          <p:nvPr/>
+        </p:nvSpPr>
+        <p:spPr>
+          <a:xfrm>
+            <a:off x="640080" y="5029200"/>
+            <a:ext cx="10789920" cy="457200"/>
+          </a:xfrm>
+          <a:prstGeom prst="rect">
+            <a:avLst/>
+          </a:prstGeom>
+          <a:noFill/>
+        </p:spPr>
+        <p:txBody>
+          <a:bodyPr wrap="square" anchor="t">
+            <a:spAutoFit/>
+          </a:bodyPr>
+          <a:lstStyle/>
+          <a:p>
+            <a:pPr algn="l">
+              <a:lnSpc>
+                <a:spcPct val="105000"/>
+              </a:lnSpc>
+            </a:pPr>
+            <a:r>
+              <a:rPr sz="1400" b="0" i="1">
+                <a:solidFill>
+                  <a:srgbClr val="94A3B8"/>
+                </a:solidFill>
+                <a:latin typeface="Calibri"/>
+              </a:rPr>
+              <a:t>A line means a public source was found. No line means no tie was found, not that none exists.</a:t>
+            </a:r>
+          </a:p>
+        </p:txBody>
+      </p:sp>
+      <p:sp>
+        <p:nvSpPr>
+          <p:cNvPr id="5" name="TextBox 4"/>
+          <p:cNvSpPr txBox="1"/>
+          <p:nvPr/>
+        </p:nvSpPr>
+        <p:spPr>
+          <a:xfrm>
+            <a:off x="640080" y="6035040"/>
+            <a:ext cx="10058400" cy="365760"/>
+          </a:xfrm>
+          <a:prstGeom prst="rect">
+            <a:avLst/>
+          </a:prstGeom>
+          <a:noFill/>
+        </p:spPr>
+        <p:txBody>
+          <a:bodyPr wrap="square" anchor="t">
+            <a:spAutoFit/>
+          </a:bodyPr>
+          <a:lstStyle/>
+          <a:p>
+            <a:pPr algn="l">
+              <a:lnSpc>
+                <a:spcPct val="105000"/>
+              </a:lnSpc>
+            </a:pPr>
+            <a:r>
+              <a:rPr sz="1200" b="0" i="0">
+                <a:solidFill>
+                  <a:srgbClr val="CBD5E1"/>
+                </a:solidFill>
+                <a:latin typeface="Calibri"/>
+              </a:rPr>
+              <a:t>Marc Pierson with Claude Opus 5.5 · September 2026</a:t>
             </a:r>
           </a:p>
         </p:txBody>

</xml_diff>